<commit_message>
Add 10-seed confidence intervals, clipping/GAE ablations, and entropy diagnostics
- Train 10 seeds by default; report seed-level 95% t-intervals for test
  metrics and plot mean ± CI learning curves.
- Add autoscaling/ablation.py: paired-seed runs of full PPO, no clipping,
  and no GAE (lambda=1 Monte Carlo, lambda=0 one-step TD), with convergence
  speed, KL and late-training stability metrics.
- Log per-rollout policy entropy, executed-action entropy (invalid actions
  mapped to hold), and probability mass on rejected actions.
- Regenerate outputs and demo video; update README, slides (18), speaker
  notes, and narration guide with the new results.

Co-Authored-By: Claude Opus 5.5 <noreply@anthropic.com>
</commit_message>
<xml_diff>
--- a/presentation/API_Autoscaling_RL_Presentation.pptx
+++ b/presentation/API_Autoscaling_RL_Presentation.pptx
@@ -20,6 +20,8 @@
     <p:sldId xmlns:r="http://schemas.openxmlformats.org/officeDocument/2006/relationships" id="265" r:id="R6d8d3627afec4f0e"/>
     <p:sldId xmlns:r="http://schemas.openxmlformats.org/officeDocument/2006/relationships" id="266" r:id="R3aca21d971d7495b"/>
     <p:sldId xmlns:r="http://schemas.openxmlformats.org/officeDocument/2006/relationships" id="267" r:id="R11d0896d39da48bb"/>
+    <p:sldId xmlns:r="http://schemas.openxmlformats.org/officeDocument/2006/relationships" id="272" r:id="rId1"/>
+    <p:sldId xmlns:r="http://schemas.openxmlformats.org/officeDocument/2006/relationships" id="273" r:id="rId2"/>
     <p:sldId xmlns:r="http://schemas.openxmlformats.org/officeDocument/2006/relationships" id="268" r:id="R0061a6c59e2d4114"/>
     <p:sldId xmlns:r="http://schemas.openxmlformats.org/officeDocument/2006/relationships" id="269" r:id="R4d0ac7f70c3e42f5"/>
     <p:sldId xmlns:r="http://schemas.openxmlformats.org/officeDocument/2006/relationships" id="270" r:id="R8aec92e4e4224cec"/>
@@ -457,7 +459,7 @@
           <a:lstStyle xmlns:a="http://schemas.openxmlformats.org/drawingml/2006/main"/>
           <a:p xmlns:a="http://schemas.openxmlformats.org/drawingml/2006/main">
             <a:r>
-              <a:t>Target: 40 seconds</a:t>
+              <a:t>Target: 35 seconds</a:t>
             </a:r>
           </a:p>
           <a:p xmlns:a="http://schemas.openxmlformats.org/drawingml/2006/main">
@@ -467,7 +469,7 @@
           </a:p>
           <a:p xmlns:a="http://schemas.openxmlformats.org/drawingml/2006/main">
             <a:r>
-              <a:t>This project asks whether a reinforcement learning agent can choose how many API replicas to run as demand changes. The challenge is familiar: too little capacity makes requests wait, while too much capacity wastes resources. In Part 1, I proposed a local simulation because I did not have a cloud setup. The completed project follows that approach. I trained PPO, compared it with two simpler controllers, and recorded the agent's decisions. The main finding is that the agent protected service better on average, but did not achieve the planned cost savings.</a:t>
+              <a:t>This project asks whether a reinforcement learning agent can choose how many API replicas to run as demand changes. Too little capacity makes requests wait, while too much capacity wastes resources. Following my Part 1 plan, I built a local simulator, trained PPO across ten random seeds, compared it with two simpler controllers, and ran ablations of PPO's main components. The main finding is that the agent protected service better on average, but did not achieve the planned cost savings.</a:t>
             </a:r>
           </a:p>
           <a:p xmlns:a="http://schemas.openxmlformats.org/drawingml/2006/main">
@@ -547,7 +549,7 @@
           <a:lstStyle xmlns:a="http://schemas.openxmlformats.org/drawingml/2006/main"/>
           <a:p xmlns:a="http://schemas.openxmlformats.org/drawingml/2006/main">
             <a:r>
-              <a:t>Target: 50 seconds</a:t>
+              <a:t>Target: 45 seconds</a:t>
             </a:r>
           </a:p>
           <a:p xmlns:a="http://schemas.openxmlformats.org/drawingml/2006/main">
@@ -557,7 +559,7 @@
           </a:p>
           <a:p xmlns:a="http://schemas.openxmlformats.org/drawingml/2006/main">
             <a:r>
-              <a:t>This chart shows mean return over the most recent twenty completed training episodes at five checkpoints. The untrained checkpoint is excluded because it has no completed training episodes. Return generally becomes less negative, but the runs do not follow identical paths. This suggests the sampled training behavior changed, not that the project achieved the practical objective. Checkpoints were chosen using validation service performance and cost, not this curve alone. Four selected policies have test violation rates near one point eight or one point nine percent. Seed two reaches five point one one percent across its test episodes. The total measured time for the five training runs was about forty-eight seconds on this execution machine, excluding plotting and video generation. That confirms the project is computationally small here, but runtime will vary on another computer. Greedy validation was already favorable before training. These results do not establish that training caused better deterministic service performance.</a:t>
+              <a:t>This chart shows the mean training return across the ten seeds, with dashed lines marking the ninety-five percent confidence interval. Return rises quickly over the first ten thousand decisions and then levels off, and the interval narrows as the seeds converge. Checkpoints were chosen on validation service and cost, not on this curve. Each fifty-thousand-decision run takes only seconds on this machine. Importantly, greedy validation was already favorable before training, so a better training return does not establish that training caused better deterministic service.</a:t>
             </a:r>
           </a:p>
           <a:p xmlns:a="http://schemas.openxmlformats.org/drawingml/2006/main">
@@ -637,7 +639,7 @@
           <a:lstStyle xmlns:a="http://schemas.openxmlformats.org/drawingml/2006/main"/>
           <a:p xmlns:a="http://schemas.openxmlformats.org/drawingml/2006/main">
             <a:r>
-              <a:t>Target: 70 seconds</a:t>
+              <a:t>Target: 60 seconds</a:t>
             </a:r>
           </a:p>
           <a:p xmlns:a="http://schemas.openxmlformats.org/drawingml/2006/main">
@@ -647,7 +649,7 @@
           </a:p>
           <a:p xmlns:a="http://schemas.openxmlformats.org/drawingml/2006/main">
             <a:r>
-              <a:t>The fixed controller averaged 14,250 replica-seconds per episode and a four point five eight percent violation rate. The threshold controller used 15,905 replica-seconds with six point five nine percent violations. PPO averaged about 17,600 replica-seconds and two point five zero percent violations. Relative to fixed capacity, PPO used twenty-three point five one percent more resources. That is the opposite of the ten-percent saving target. Its lower violation rate is useful, but it is not enough to call the overall project successful. A diagnostic is especially revealing: PPO averaged about 172 invalid actions per episode, out of 180 decisions. The policies often continue requesting additions after reaching the capacity limit. Those actions do nothing, so the agent can behave almost like a high fixed-capacity controller. The mean test return is also slightly worse than the fixed baseline. This reinforces why separate service and cost metrics are more informative than a favorable training curve.</a:t>
+              <a:t>The fixed controller averaged 14,250 replica-seconds and a four point five eight percent violation rate. The threshold controller used 15,905 replica-seconds with six point five nine percent violations. Across ten seeds, PPO averaged about 17,650 replica-seconds and two point two one percent violations, with a confidence interval from about one point five to two point nine percent. Relative to fixed capacity, PPO used twenty-three point eight five percent more resources, the opposite of the ten-percent saving target. A diagnostic is revealing: PPO averaged about 167 invalid actions per episode, out of 180 decisions. The policies keep requesting additions after reaching the capacity limit. Those actions do nothing, so the agent behaves almost like a high fixed-capacity controller.</a:t>
             </a:r>
           </a:p>
           <a:p xmlns:a="http://schemas.openxmlformats.org/drawingml/2006/main">
@@ -727,7 +729,7 @@
           <a:lstStyle xmlns:a="http://schemas.openxmlformats.org/drawingml/2006/main"/>
           <a:p xmlns:a="http://schemas.openxmlformats.org/drawingml/2006/main">
             <a:r>
-              <a:t>Target: 55 seconds</a:t>
+              <a:t>Target: 50 seconds</a:t>
             </a:r>
           </a:p>
           <a:p xmlns:a="http://schemas.openxmlformats.org/drawingml/2006/main">
@@ -737,7 +739,7 @@
           </a:p>
           <a:p xmlns:a="http://schemas.openxmlformats.org/drawingml/2006/main">
             <a:r>
-              <a:t>Breaking results down changes the interpretation. PPO's mean violation rate is five point zero five percent on steady traffic, two point three nine percent on periodic traffic, and only point zero six percent on bursty traffic. The fixed controller does better on steady traffic, but misses eight point three three percent on bursts. The threshold controller misses thirteen point four seven percent on bursts. Extra capacity is therefore especially helpful in the burst tests, while one weaker PPO run raises the steady average above the five-percent limit. The range across PPO training seeds is about one point eight one to five point one one percent when averaged across all workloads. I would not hide that weaker run or present one favorable demo as the overall outcome. The cost condition fails clearly, and the per-workload service condition also fails narrowly.</a:t>
+              <a:t>Breaking results down by workload changes the interpretation. PPO's mean violation rate is four point one eight percent on steady traffic, two point three eight percent on periodic traffic, and only point zero six percent on bursts. The fixed controller misses eight point three three percent on bursts and the threshold controller thirteen point four seven percent, so extra capacity helps most with bursts. But on steady traffic the PPO confidence interval runs from about two to six point three percent, crossing the five-percent limit. Across seeds, overall violations range from one point eight one to five point one one percent. So the cost condition fails clearly, and the per-workload service condition is not met with confidence.</a:t>
             </a:r>
           </a:p>
           <a:p xmlns:a="http://schemas.openxmlformats.org/drawingml/2006/main">
@@ -827,7 +829,7 @@
           </a:p>
           <a:p xmlns:a="http://schemas.openxmlformats.org/drawingml/2006/main">
             <a:r>
-              <a:t>I will now play a sixty-second replay of actual evaluated decisions. It contains three twenty-second segments: steady, periodic, and bursty traffic. Each segment represents thirty simulated minutes. The full curves are visible, and the moving cursor marks the replay time. The gray curve is demand, orange is active service capacity, and green is the queue. The bottom panel tracks cumulative violations among resolved requests. Watch the initial capacity ramp and then the large amount of spare capacity. During periodic traffic, demand falls but the selected policy largely keeps its capacity. On bursty traffic, that spare capacity helps absorb peaks. The demo uses seed two, chosen by validation rather than by test appearance, and three predetermined test traces. It illustrates actual behavior, including inefficiency. It does not demonstrate production readiness or replace the full test results.</a:t>
+              <a:t>I will now play a sixty-second replay of actual evaluated decisions, with three twenty-second segments: steady, periodic, and bursty traffic. Each segment represents thirty simulated minutes. The full curves are visible, and the moving cursor marks the replay time. The gray curve is demand, orange is active capacity, and green is the queue. The bottom panel tracks cumulative violations among resolved requests. Watch the initial capacity ramp and then the large amount of spare capacity. During periodic traffic, demand falls but the policy largely keeps its capacity. On bursty traffic, that spare capacity absorbs peaks. The demo uses seed one, chosen by validation rather than by test appearance, and three predetermined test traces. It illustrates actual behavior, including inefficiency, and does not replace the full test results.</a:t>
             </a:r>
           </a:p>
           <a:p xmlns:a="http://schemas.openxmlformats.org/drawingml/2006/main">
@@ -907,7 +909,7 @@
           <a:lstStyle xmlns:a="http://schemas.openxmlformats.org/drawingml/2006/main"/>
           <a:p xmlns:a="http://schemas.openxmlformats.org/drawingml/2006/main">
             <a:r>
-              <a:t>Target: 55 seconds</a:t>
+              <a:t>Target: 45 seconds</a:t>
             </a:r>
           </a:p>
           <a:p xmlns:a="http://schemas.openxmlformats.org/drawingml/2006/main">
@@ -917,7 +919,7 @@
           </a:p>
           <a:p xmlns:a="http://schemas.openxmlformats.org/drawingml/2006/main">
             <a:r>
-              <a:t>A real autoscaler controls both service access and resource spending. Underprovisioning can delay or drop requests, and the impact may fall unevenly on different users or time periods. This simulator has no user identities or priority classes, so it does not evaluate fairness. Overprovisioning can also waste money and energy. Replica-seconds provide a limited resource measure, not a measured carbon estimate. For a real deployment, I would require hard capacity and budget limits, a fallback controller, monitoring, and a way to roll back unsafe behavior. Exploration should happen in a sandbox or carefully controlled setting. These experiments use synthetic data and no live cloud service. I would remain accountable for the choices in the reward and simulator rather than assuming the agent's learned behavior is automatically acceptable.</a:t>
+              <a:t>A real autoscaler controls both service access and resource spending. Underprovisioning can delay or drop requests, and the impact may fall unevenly on users; this simulator has no user groups, so it does not evaluate fairness. Overprovisioning wastes money and energy, and replica-seconds are not a measured carbon estimate. A real deployment would need hard capacity and budget limits, a fallback controller, monitoring, and rollback, with exploration kept in a sandbox. I remain accountable for the reward and simulator choices rather than assuming the learned behavior is automatically acceptable.</a:t>
             </a:r>
           </a:p>
           <a:p xmlns:a="http://schemas.openxmlformats.org/drawingml/2006/main">
@@ -997,7 +999,7 @@
           <a:lstStyle xmlns:a="http://schemas.openxmlformats.org/drawingml/2006/main"/>
           <a:p xmlns:a="http://schemas.openxmlformats.org/drawingml/2006/main">
             <a:r>
-              <a:t>Target: 45 seconds</a:t>
+              <a:t>Target: 40 seconds</a:t>
             </a:r>
           </a:p>
           <a:p xmlns:a="http://schemas.openxmlformats.org/drawingml/2006/main">
@@ -1007,7 +1009,7 @@
           </a:p>
           <a:p xmlns:a="http://schemas.openxmlformats.org/drawingml/2006/main">
             <a:r>
-              <a:t>The project produced a working local simulator, a trained PPO implementation, two baselines, reproducible logs, and a replay. The main lesson is that learning a policy is different from meeting the intended operational goal. In these tests, the learned controller traded higher capacity for better average service and failed the cost target. Next I would mask invalid actions consistently during both training and evaluation, then investigate reward balance and the difference between interval and episode metrics. I would add stronger predictive or rule-based baselines, more workload variation, and longer repeated experiments. Each change should use validation for tuning and a fresh held-out test set. Real traces would be a later step, after improving the simulator evidence. For now, the defensible conclusion is a useful prototype with clear limitations.</a:t>
+              <a:t>The project produced a working simulator, a tested PPO implementation, two baselines, ten-seed results with confidence intervals, component ablations, and a replay. The main lesson is that learning a policy is different from meeting the operational goal. The entropy diagnostic points to the first next step: mask invalid actions during training and evaluation. Then I would revisit reward balance, add stronger baselines, and broaden workloads, with validation for tuning and fresh held-out tests. The defensible conclusion is a useful prototype with clear limitations.</a:t>
             </a:r>
           </a:p>
           <a:p xmlns:a="http://schemas.openxmlformats.org/drawingml/2006/main">
@@ -1087,7 +1089,7 @@
           <a:lstStyle xmlns:a="http://schemas.openxmlformats.org/drawingml/2006/main"/>
           <a:p xmlns:a="http://schemas.openxmlformats.org/drawingml/2006/main">
             <a:r>
-              <a:t>Target: 30 seconds</a:t>
+              <a:t>Target: 25 seconds</a:t>
             </a:r>
           </a:p>
           <a:p xmlns:a="http://schemas.openxmlformats.org/drawingml/2006/main">
@@ -1097,7 +1099,7 @@
           </a:p>
           <a:p xmlns:a="http://schemas.openxmlformats.org/drawingml/2006/main">
             <a:r>
-              <a:t>The references here connect back to Part 1, and full links are included in the repository and speaker notes. OpenAI ChatGPT helped implement and test code, organize the experiment, analyze measured outputs, and draft these slides and narration. I need to review and understand that assistance, verify the sources, and explain the final work in my own words. The results shown come from actual simulator runs.</a:t>
+              <a:t>The references connect back to Part 1, and full links are in the repository. OpenAI ChatGPT and Anthropic Claude helped implement and test code, run and analyze the experiments, and draft these slides and narration. I need to review that assistance, verify the sources, and explain the work in my own words. The results come from actual simulator runs.</a:t>
             </a:r>
           </a:p>
           <a:p xmlns:a="http://schemas.openxmlformats.org/drawingml/2006/main">
@@ -1158,6 +1160,186 @@
           <a:p xmlns:a="http://schemas.openxmlformats.org/drawingml/2006/main">
             <a:r>
               <a:t>Henderson et al. (2017). Deep Reinforcement Learning that Matters. https://arxiv.org/abs/1709.06560</a:t>
+            </a:r>
+          </a:p>
+        </p:txBody>
+      </p:sp>
+      <p:sp>
+        <p:nvSpPr>
+          <p:cNvPr id="4" name="Slide Number Placeholder 3"/>
+          <p:cNvSpPr>
+            <a:spLocks xmlns:a="http://schemas.openxmlformats.org/drawingml/2006/main" noGrp="1"/>
+          </p:cNvSpPr>
+          <p:nvPr>
+            <p:ph type="sldNum" idx="5"/>
+          </p:nvPr>
+        </p:nvSpPr>
+        <p:spPr/>
+        <p:txBody>
+          <a:bodyPr xmlns:a="http://schemas.openxmlformats.org/drawingml/2006/main"/>
+          <a:lstStyle xmlns:a="http://schemas.openxmlformats.org/drawingml/2006/main"/>
+          <a:p xmlns:a="http://schemas.openxmlformats.org/drawingml/2006/main"/>
+        </p:txBody>
+      </p:sp>
+    </p:spTree>
+  </p:cSld>
+  <p:clrMapOvr>
+    <a:masterClrMapping xmlns:a="http://schemas.openxmlformats.org/drawingml/2006/main"/>
+  </p:clrMapOvr>
+</p:notes>
+</file>
+
+<file path=ppt/notesSlides/notesSlide17.xml><?xml version="1.0" encoding="utf-8"?>
+<p:notes xmlns:p="http://schemas.openxmlformats.org/presentationml/2006/main">
+  <p:cSld>
+    <p:spTree>
+      <p:nvGrpSpPr>
+        <p:cNvPr id="1" name=""/>
+        <p:cNvGrpSpPr/>
+        <p:nvPr/>
+      </p:nvGrpSpPr>
+      <p:grpSpPr>
+        <a:xfrm xmlns:a="http://schemas.openxmlformats.org/drawingml/2006/main"/>
+      </p:grpSpPr>
+      <p:sp>
+        <p:nvSpPr>
+          <p:cNvPr id="2" name="Slide Image Placeholder 1"/>
+          <p:cNvSpPr>
+            <a:spLocks xmlns:a="http://schemas.openxmlformats.org/drawingml/2006/main" noGrp="1"/>
+          </p:cNvSpPr>
+          <p:nvPr>
+            <p:ph type="sldImg" idx="0"/>
+          </p:nvPr>
+        </p:nvSpPr>
+        <p:spPr/>
+      </p:sp>
+      <p:sp>
+        <p:nvSpPr>
+          <p:cNvPr id="3" name="Notes Placeholder 2"/>
+          <p:cNvSpPr>
+            <a:spLocks xmlns:a="http://schemas.openxmlformats.org/drawingml/2006/main" noGrp="1"/>
+          </p:cNvSpPr>
+          <p:nvPr>
+            <p:ph type="body" idx="1"/>
+          </p:nvPr>
+        </p:nvSpPr>
+        <p:spPr/>
+        <p:txBody>
+          <a:bodyPr xmlns:a="http://schemas.openxmlformats.org/drawingml/2006/main"/>
+          <a:lstStyle xmlns:a="http://schemas.openxmlformats.org/drawingml/2006/main"/>
+          <a:p xmlns:a="http://schemas.openxmlformats.org/drawingml/2006/main">
+            <a:r>
+              <a:t>Target: 55 seconds</a:t>
+            </a:r>
+          </a:p>
+          <a:p xmlns:a="http://schemas.openxmlformats.org/drawingml/2006/main">
+            <a:r>
+              <a:t/>
+            </a:r>
+          </a:p>
+          <a:p xmlns:a="http://schemas.openxmlformats.org/drawingml/2006/main">
+            <a:r>
+              <a:t>To measure what PPO's components contribute, I retrained ten paired seeds for three variants: no clipping, and two ways of removing GAE, Monte Carlo returns with lambda one and one-step TD with lambda zero. Paired means each seed starts every variant from the same weights and traffic. Without clipping, training reaches the convergence threshold about a thousand decisions sooner, but the largest update KL jumps from about point zero one five to point six, and one run collapsed to minimum capacity by the end. Lambda one is statistically indistinguishable from full PPO here, because episodes are short. Lambda zero is the slowest, about twenty-nine hundred decisions behind, and the least stable. Validation checkpoint selection hides the collapses, so test metrics barely change.</a:t>
+            </a:r>
+          </a:p>
+          <a:p xmlns:a="http://schemas.openxmlformats.org/drawingml/2006/main">
+            <a:r>
+              <a:t/>
+            </a:r>
+          </a:p>
+          <a:p xmlns:a="http://schemas.openxmlformats.org/drawingml/2006/main">
+            <a:r>
+              <a:t>Sources: Measured outputs/ablations/summary.json, summary.md, runs.csv and training_seed*.csv.</a:t>
+            </a:r>
+          </a:p>
+        </p:txBody>
+      </p:sp>
+      <p:sp>
+        <p:nvSpPr>
+          <p:cNvPr id="4" name="Slide Number Placeholder 3"/>
+          <p:cNvSpPr>
+            <a:spLocks xmlns:a="http://schemas.openxmlformats.org/drawingml/2006/main" noGrp="1"/>
+          </p:cNvSpPr>
+          <p:nvPr>
+            <p:ph type="sldNum" idx="5"/>
+          </p:nvPr>
+        </p:nvSpPr>
+        <p:spPr/>
+        <p:txBody>
+          <a:bodyPr xmlns:a="http://schemas.openxmlformats.org/drawingml/2006/main"/>
+          <a:lstStyle xmlns:a="http://schemas.openxmlformats.org/drawingml/2006/main"/>
+          <a:p xmlns:a="http://schemas.openxmlformats.org/drawingml/2006/main"/>
+        </p:txBody>
+      </p:sp>
+    </p:spTree>
+  </p:cSld>
+  <p:clrMapOvr>
+    <a:masterClrMapping xmlns:a="http://schemas.openxmlformats.org/drawingml/2006/main"/>
+  </p:clrMapOvr>
+</p:notes>
+</file>
+
+<file path=ppt/notesSlides/notesSlide18.xml><?xml version="1.0" encoding="utf-8"?>
+<p:notes xmlns:p="http://schemas.openxmlformats.org/presentationml/2006/main">
+  <p:cSld>
+    <p:spTree>
+      <p:nvGrpSpPr>
+        <p:cNvPr id="1" name=""/>
+        <p:cNvGrpSpPr/>
+        <p:nvPr/>
+      </p:nvGrpSpPr>
+      <p:grpSpPr>
+        <a:xfrm xmlns:a="http://schemas.openxmlformats.org/drawingml/2006/main"/>
+      </p:grpSpPr>
+      <p:sp>
+        <p:nvSpPr>
+          <p:cNvPr id="2" name="Slide Image Placeholder 1"/>
+          <p:cNvSpPr>
+            <a:spLocks xmlns:a="http://schemas.openxmlformats.org/drawingml/2006/main" noGrp="1"/>
+          </p:cNvSpPr>
+          <p:nvPr>
+            <p:ph type="sldImg" idx="0"/>
+          </p:nvPr>
+        </p:nvSpPr>
+        <p:spPr/>
+      </p:sp>
+      <p:sp>
+        <p:nvSpPr>
+          <p:cNvPr id="3" name="Notes Placeholder 2"/>
+          <p:cNvSpPr>
+            <a:spLocks xmlns:a="http://schemas.openxmlformats.org/drawingml/2006/main" noGrp="1"/>
+          </p:cNvSpPr>
+          <p:nvPr>
+            <p:ph type="body" idx="1"/>
+          </p:nvPr>
+        </p:nvSpPr>
+        <p:spPr/>
+        <p:txBody>
+          <a:bodyPr xmlns:a="http://schemas.openxmlformats.org/drawingml/2006/main"/>
+          <a:lstStyle xmlns:a="http://schemas.openxmlformats.org/drawingml/2006/main"/>
+          <a:p xmlns:a="http://schemas.openxmlformats.org/drawingml/2006/main">
+            <a:r>
+              <a:t>Target: 45 seconds</a:t>
+            </a:r>
+          </a:p>
+          <a:p xmlns:a="http://schemas.openxmlformats.org/drawingml/2006/main">
+            <a:r>
+              <a:t/>
+            </a:r>
+          </a:p>
+          <a:p xmlns:a="http://schemas.openxmlformats.org/drawingml/2006/main">
+            <a:r>
+              <a:t>The entropy bonus acts on the policy's three-way action distribution. But the environment turns invalid actions into holds, so I also log the entropy of the actions that actually execute. The two diverge sharply. At the end of training, policy entropy is about point six four nats, but executed entropy is only point one seven, and sixty-three percent of the probability sits on actions the environment rejects. The policy looks exploratory to the loss, but most of that randomness is a choice between add and hold at the ceiling, which both mean hold. That explains the invalid-action counts, and it motivates masking invalid actions.</a:t>
+            </a:r>
+          </a:p>
+          <a:p xmlns:a="http://schemas.openxmlformats.org/drawingml/2006/main">
+            <a:r>
+              <a:t/>
+            </a:r>
+          </a:p>
+          <a:p xmlns:a="http://schemas.openxmlformats.org/drawingml/2006/main">
+            <a:r>
+              <a:t>Sources: Measured outputs/training_seed*.csv (policy_entropy, executed_entropy, invalid_mass) and outputs/entropy.png.</a:t>
             </a:r>
           </a:p>
         </p:txBody>
@@ -1227,7 +1409,7 @@
           <a:lstStyle xmlns:a="http://schemas.openxmlformats.org/drawingml/2006/main"/>
           <a:p xmlns:a="http://schemas.openxmlformats.org/drawingml/2006/main">
             <a:r>
-              <a:t>Target: 55 seconds</a:t>
+              <a:t>Target: 50 seconds</a:t>
             </a:r>
           </a:p>
           <a:p xmlns:a="http://schemas.openxmlformats.org/drawingml/2006/main">
@@ -1237,7 +1419,7 @@
           </a:p>
           <a:p xmlns:a="http://schemas.openxmlformats.org/drawingml/2006/main">
             <a:r>
-              <a:t>The original objective had two parts. First, at least 95 percent of requests should meet a two-second waiting target. Second, PPO should use at least ten percent less capacity than the fixed controller. I treat both conditions as necessary for success, and check the waiting target separately for steady, periodic, and bursty traffic. This is a sequential decision problem because an extra replica takes time to start. A decision that looks expensive now may prevent a queue later. A removal that looks efficient now may leave the service unprepared for a burst. That delayed consequence is the reason reinforcement learning is a reasonable approach. Capacity is measured in replica-seconds, which is a resource proxy rather than a cloud bill.</a:t>
+              <a:t>The original objective had two parts. First, at least 95 percent of requests should meet a two-second waiting target. Second, PPO should use at least ten percent less capacity than the fixed controller. I treat both conditions as necessary, and check the waiting target separately for steady, periodic, and bursty traffic. This is a sequential decision problem because an extra replica takes time to start. A decision that looks expensive now may prevent a queue later, and a removal that looks efficient now may leave the service unprepared for a burst. That delayed consequence is why reinforcement learning is a reasonable approach. Capacity is measured in replica-seconds, a resource proxy rather than a cloud bill.</a:t>
             </a:r>
           </a:p>
           <a:p xmlns:a="http://schemas.openxmlformats.org/drawingml/2006/main">
@@ -1317,7 +1499,7 @@
           <a:lstStyle xmlns:a="http://schemas.openxmlformats.org/drawingml/2006/main"/>
           <a:p xmlns:a="http://schemas.openxmlformats.org/drawingml/2006/main">
             <a:r>
-              <a:t>Target: 45 seconds</a:t>
+              <a:t>Target: 40 seconds</a:t>
             </a:r>
           </a:p>
           <a:p xmlns:a="http://schemas.openxmlformats.org/drawingml/2006/main">
@@ -1327,7 +1509,7 @@
           </a:p>
           <a:p xmlns:a="http://schemas.openxmlformats.org/drawingml/2006/main">
             <a:r>
-              <a:t>The research helped me choose both the method and the scope. Barrett and colleagues and the survey by Gari and colleagues connect reinforcement learning to cloud resource allocation and autoscaling. Wang and colleagues also study provisioning in simulation, which supports a simulator as a useful starting point. PPO provides a clipped policy update, and generalized advantage estimation helps estimate which sampled actions were better than expected. Henderson and colleagues emphasize variability and reproducibility, which motivated multiple training seeds and separate evaluation workloads. AWARE also makes clear that production autoscaling requires much more system integration than this project includes. These papers inform the design; the project is not a reproduction of their reported production results.</a:t>
+              <a:t>Barrett and colleagues and the survey by Gari and colleagues connect reinforcement learning to cloud resource allocation and autoscaling. Wang and colleagues study provisioning in simulation, which supports a simulator as a starting point. PPO provides a clipped policy update, and generalized advantage estimation helps judge which sampled actions were better than expected. Henderson and colleagues emphasize variability across random seeds, which motivated ten training seeds with confidence intervals. AWARE makes clear that production autoscaling needs much more system integration than this project includes. These papers inform the design; the project does not reproduce their results.</a:t>
             </a:r>
           </a:p>
           <a:p xmlns:a="http://schemas.openxmlformats.org/drawingml/2006/main">
@@ -1457,7 +1639,7 @@
           <a:lstStyle xmlns:a="http://schemas.openxmlformats.org/drawingml/2006/main"/>
           <a:p xmlns:a="http://schemas.openxmlformats.org/drawingml/2006/main">
             <a:r>
-              <a:t>Target: 60 seconds</a:t>
+              <a:t>Target: 50 seconds</a:t>
             </a:r>
           </a:p>
           <a:p xmlns:a="http://schemas.openxmlformats.org/drawingml/2006/main">
@@ -1467,7 +1649,7 @@
           </a:p>
           <a:p xmlns:a="http://schemas.openxmlformats.org/drawingml/2006/main">
             <a:r>
-              <a:t>Each episode represents thirty minutes of arrivals. The controller acts every ten seconds, starting with two active replicas. One replica can serve twenty requests per second, and a new replica takes twenty seconds to become active. The capacity range is one to ten replicas. Requests join a first-in, first-out queue with a thousand-request limit. A request violates the service target if it waits more than two seconds, expires after ten seconds, or is dropped because the queue is full. Once arrivals end, I freeze capacity and drain the queue so unfinished work is still counted. Steady, periodic, and bursty rate profiles produce seeded Poisson arrivals. These are synthetic workloads, not customer traffic. The waiting metric excludes network delay and application processing, so it should not be presented as a complete production latency guarantee.</a:t>
+              <a:t>Each episode represents thirty minutes of arrivals. The controller acts every ten seconds, starting with two active replicas. One replica serves twenty requests per second, and a new replica takes twenty seconds to become active. Capacity ranges from one to ten replicas. Requests join a first-in, first-out queue with a thousand-request limit. A request violates the service target if it waits more than two seconds, expires after ten seconds, or is dropped because the queue is full. After arrivals end, I drain the queue so unfinished work still counts. Steady, periodic, and bursty profiles produce seeded Poisson arrivals. These are synthetic workloads, and the waiting metric excludes network and processing time.</a:t>
             </a:r>
           </a:p>
           <a:p xmlns:a="http://schemas.openxmlformats.org/drawingml/2006/main">
@@ -1547,7 +1729,7 @@
           <a:lstStyle xmlns:a="http://schemas.openxmlformats.org/drawingml/2006/main"/>
           <a:p xmlns:a="http://schemas.openxmlformats.org/drawingml/2006/main">
             <a:r>
-              <a:t>Target: 50 seconds</a:t>
+              <a:t>Target: 40 seconds</a:t>
             </a:r>
           </a:p>
           <a:p xmlns:a="http://schemas.openxmlformats.org/drawingml/2006/main">
@@ -1557,7 +1739,7 @@
           </a:p>
           <a:p xmlns:a="http://schemas.openxmlformats.org/drawingml/2006/main">
             <a:r>
-              <a:t>The agent receives nine normalized observations. They summarize recent arrivals, a short moving average, the change in demand, queue size and age, active capacity, two stages of replicas still starting, and utilization. The actions are simple: remove one replica, hold capacity, or add one replica. A removal cannot take active capacity below one, and an addition cannot exceed ten allocated replicas. Invalid actions become no-ops and are recorded. The observation is deliberately compact, but it does not reveal future demand or every queue cohort. That makes the task partially observable. The network is feed-forward, so it cannot perfectly reconstruct hidden history. This limitation matters when interpreting why a policy reacts well to some workloads and poorly to others.</a:t>
+              <a:t>The agent receives nine normalized observations: recent arrivals, a short moving average, the change in demand, queue size and age, active capacity, two stages of starting replicas, and utilization. The actions are remove one replica, hold, or add one. A removal cannot go below one active replica, and an addition cannot exceed ten allocated replicas. Invalid actions become no-ops and are recorded; that detail becomes important later. The observation does not reveal future demand, so the task is partially observable.</a:t>
             </a:r>
           </a:p>
           <a:p xmlns:a="http://schemas.openxmlformats.org/drawingml/2006/main">
@@ -1637,7 +1819,7 @@
           <a:lstStyle xmlns:a="http://schemas.openxmlformats.org/drawingml/2006/main"/>
           <a:p xmlns:a="http://schemas.openxmlformats.org/drawingml/2006/main">
             <a:r>
-              <a:t>Target: 55 seconds</a:t>
+              <a:t>Target: 45 seconds</a:t>
             </a:r>
           </a:p>
           <a:p xmlns:a="http://schemas.openxmlformats.org/drawingml/2006/main">
@@ -1647,7 +1829,7 @@
           </a:p>
           <a:p xmlns:a="http://schemas.openxmlformats.org/drawingml/2006/main">
             <a:r>
-              <a:t>The reward is the negative sum of four penalties. Allocated capacity has a weight of point one, the fraction of resolved requests that violate the target has a weight of five, normalized queue size has a weight of point five, and each successful scaling change costs point zero two. Starting replicas count toward capacity cost before they serve requests. The violation fraction uses requests resolved in the current interval; if none resolve, that term is zero. This is not the same aggregation as the final episode metric, and that mismatch is a limitation. I retained the initial weights rather than tuning them extensively. The much larger service penalty makes protecting requests attractive, but does not guarantee economical behavior. The resulting policy suggests that the balance needs more careful study.</a:t>
+              <a:t>The reward is the negative sum of four penalties. Allocated capacity has a weight of point one, the fraction of resolved requests that violate the target has a weight of five, normalized queue size has a weight of point five, and each successful scaling change costs point zero two. Starting replicas count toward capacity cost. The violation fraction uses requests resolved in the current interval, which is not the same aggregation as the final episode metric. I kept the initial weights rather than tuning them. The large service penalty makes protecting requests attractive, but does not guarantee economical behavior.</a:t>
             </a:r>
           </a:p>
           <a:p xmlns:a="http://schemas.openxmlformats.org/drawingml/2006/main">
@@ -1727,7 +1909,7 @@
           <a:lstStyle xmlns:a="http://schemas.openxmlformats.org/drawingml/2006/main"/>
           <a:p xmlns:a="http://schemas.openxmlformats.org/drawingml/2006/main">
             <a:r>
-              <a:t>Target: 65 seconds</a:t>
+              <a:t>Target: 55 seconds</a:t>
             </a:r>
           </a:p>
           <a:p xmlns:a="http://schemas.openxmlformats.org/drawingml/2006/main">
@@ -1737,7 +1919,7 @@
           </a:p>
           <a:p xmlns:a="http://schemas.openxmlformats.org/drawingml/2006/main">
             <a:r>
-              <a:t>PPO uses an actor to assign probabilities to the three actions and a critic to estimate future discounted return. Both networks have two hidden layers of sixty-four units with tanh activation. Their nine inputs are the observations. The actor has three outputs and the critic has one. During training, the policy samples actions, gathers a rollout, and computes advantages using the critic and generalized advantage estimation. The clipped objective limits how much the new action probability can move relative to the policy that collected the data. Here the clip range is point two, the discount is point nine nine, and the GAE parameter is point nine five. I use Adam with a learning rate of three times ten to the minus four. Each rollout has 1,024 decisions, followed by ten optimization epochs in minibatches up to sixty-four. At test time, I choose the most probable action, so evaluation is deterministic for a fixed workload.</a:t>
+              <a:t>The actor assigns probabilities to the three actions, and the critic estimates future discounted return. Both networks have two hidden layers of sixty-four tanh units. During training, the policy samples actions, gathers a rollout, and computes advantages with generalized advantage estimation. The clipped objective limits how far the new action probability can move from the policy that collected the data. The clip range is point two, the discount is point nine nine, and the GAE parameter is point nine five. Adam uses a learning rate of three times ten to the minus four, with an entropy bonus of point zero one. Each rollout has 1,024 decisions, followed by ten epochs in minibatches up to sixty-four. At test time I choose the most probable action, so evaluation is deterministic.</a:t>
             </a:r>
           </a:p>
           <a:p xmlns:a="http://schemas.openxmlformats.org/drawingml/2006/main">
@@ -1867,7 +2049,7 @@
           <a:lstStyle xmlns:a="http://schemas.openxmlformats.org/drawingml/2006/main"/>
           <a:p xmlns:a="http://schemas.openxmlformats.org/drawingml/2006/main">
             <a:r>
-              <a:t>Target: 55 seconds</a:t>
+              <a:t>Target: 45 seconds</a:t>
             </a:r>
           </a:p>
           <a:p xmlns:a="http://schemas.openxmlformats.org/drawingml/2006/main">
@@ -1877,7 +2059,7 @@
           </a:p>
           <a:p xmlns:a="http://schemas.openxmlformats.org/drawingml/2006/main">
             <a:r>
-              <a:t>The implementation separates the simulator, controllers, PPO training, experiment runner, and analysis. NumPy handles the networks, manual gradients, and Adam; Matplotlib creates the plots and FFmpeg encodes the replay. The biggest change from Part 1 is the framework. PyTorch and Gymnasium were unavailable in the execution workspace, so the project uses NumPy and Gymnasium-style reset and step signatures. It does not claim to be a registered Gymnasium environment. I kept PPO and the planned network sizes. DQN remains an alternative rather than a completed comparison. Five tests check policy and network gradients numerically, terminal advantage calculations, startup timing and request accounting, and seeded reproducibility. I also corrected a timing boundary so a replica that finishes starting is visible at the next decision. These checks support the implementation, although they cannot prove every modeling assumption is realistic.</a:t>
+              <a:t>The code separates the simulator, controllers, PPO training, the experiment and ablation runners, and analysis. NumPy handles the networks, manual gradients, and Adam. The biggest change from Part 1 is the framework: PyTorch and Gymnasium were unavailable, so I used NumPy with Gymnasium-style reset and step signatures. DQN remains an alternative, not a completed comparison. Nine tests check the gradients numerically with and without clipping, advantages at terminal steps and at lambda zero and one, the entropy diagnostics, startup timing and request accounting, and seeded reproducibility.</a:t>
             </a:r>
           </a:p>
           <a:p xmlns:a="http://schemas.openxmlformats.org/drawingml/2006/main">
@@ -1957,7 +2139,7 @@
           <a:lstStyle xmlns:a="http://schemas.openxmlformats.org/drawingml/2006/main"/>
           <a:p xmlns:a="http://schemas.openxmlformats.org/drawingml/2006/main">
             <a:r>
-              <a:t>Target: 50 seconds</a:t>
+              <a:t>Target: 45 seconds</a:t>
             </a:r>
           </a:p>
           <a:p xmlns:a="http://schemas.openxmlformats.org/drawingml/2006/main">
@@ -1967,7 +2149,7 @@
           </a:p>
           <a:p xmlns:a="http://schemas.openxmlformats.org/drawingml/2006/main">
             <a:r>
-              <a:t>I trained five independent seeds for fifty thousand decisions each. Twenty validation traces select checkpoints and tune the baseline settings. The final test set has thirty different traces, with ten for each workload type. All controllers receive the same test arrivals and start with two active replicas. Validation selected eight replicas for the fixed controller; it ramps up through the same startup process rather than receiving instant capacity. The threshold controller uses upper utilization point six, lower utilization point two, and a ten-second cooldown. Low utilization must persist for three decisions with an empty queue before downscaling. PPO is evaluated as five trained policies on the same thirty traces. Those are 150 policy-trace evaluations, not 150 independent workloads. Reported summaries average episode metrics. They are descriptive results, without a statistical significance claim.</a:t>
+              <a:t>I trained ten independent seeds for fifty thousand decisions each. Twenty validation traces select checkpoints and tune the baselines. The test set has thirty different traces, ten per workload type, and every controller receives the same arrivals. Validation selected eight replicas for the fixed controller, and threshold settings of point six and point two with a ten-second cooldown. PPO is evaluated as ten policies on the same thirty traces. That is three hundred policy-trace evaluations, not three hundred independent workloads, so I treat each training seed as one sample and report ninety-five percent confidence intervals across the ten seeds.</a:t>
             </a:r>
           </a:p>
           <a:p xmlns:a="http://schemas.openxmlformats.org/drawingml/2006/main">
@@ -4251,7 +4433,7 @@
                 <a:ea typeface="DejaVu Sans"/>
                 <a:cs typeface="DejaVu Sans"/>
               </a:rPr>
-              <a:t>Training return by seed</a:t>
+              <a:t>Training return: mean and 95% CI across 10 seeds</a:t>
             </a:r>
           </a:p>
         </c:rich>
@@ -4282,12 +4464,12 @@
           <c:idx val="0"/>
           <c:order val="0"/>
           <c:tx>
-            <c:v>Seed 0</c:v>
+            <c:v>Mean of 10 seeds</c:v>
           </c:tx>
           <c:spPr>
-            <a:ln xmlns:a="http://schemas.openxmlformats.org/drawingml/2006/main" w="28575">
+            <a:ln xmlns:a="http://schemas.openxmlformats.org/drawingml/2006/main" w="34925">
               <a:solidFill>
-                <a:srgbClr val="172D44"/>
+                <a:srgbClr val="DC7841"/>
               </a:solidFill>
             </a:ln>
           </c:spPr>
@@ -4296,23 +4478,38 @@
           </c:marker>
           <c:cat>
             <c:numRef>
-              <c:f>'Chart Data'!$A$2:$A$6</c:f>
+              <c:f>'Chart Data'!$A$2:$A$11</c:f>
               <c:numCache>
                 <c:formatCode>General</c:formatCode>
-                <c:ptCount val="5"/>
+                <c:ptCount val="10"/>
                 <c:pt idx="0">
+                  <c:v>5.12</c:v>
+                </c:pt>
+                <c:pt idx="1">
                   <c:v>10.24</c:v>
                 </c:pt>
-                <c:pt idx="1">
+                <c:pt idx="2">
+                  <c:v>15.36</c:v>
+                </c:pt>
+                <c:pt idx="3">
                   <c:v>20.48</c:v>
                 </c:pt>
-                <c:pt idx="2">
+                <c:pt idx="4">
+                  <c:v>25.6</c:v>
+                </c:pt>
+                <c:pt idx="5">
                   <c:v>30.72</c:v>
                 </c:pt>
-                <c:pt idx="3">
+                <c:pt idx="6">
+                  <c:v>35.84</c:v>
+                </c:pt>
+                <c:pt idx="7">
                   <c:v>40.96</c:v>
                 </c:pt>
-                <c:pt idx="4">
+                <c:pt idx="8">
+                  <c:v>46.08</c:v>
+                </c:pt>
+                <c:pt idx="9">
                   <c:v>50</c:v>
                 </c:pt>
               </c:numCache>
@@ -4320,24 +4517,39 @@
           </c:cat>
           <c:val>
             <c:numRef>
-              <c:f>'Chart Data'!$B$2:$B$6</c:f>
+              <c:f>'Chart Data'!$B$2:$B$11</c:f>
               <c:numCache>
-                <c:formatCode>0</c:formatCode>
-                <c:ptCount val="5"/>
+                <c:formatCode>0.0</c:formatCode>
+                <c:ptCount val="10"/>
                 <c:pt idx="0">
-                  <c:v>-73.1428</c:v>
+                  <c:v>-117.298</c:v>
                 </c:pt>
                 <c:pt idx="1">
-                  <c:v>-34.8382</c:v>
+                  <c:v>-47.9571</c:v>
                 </c:pt>
                 <c:pt idx="2">
-                  <c:v>-24.9245</c:v>
+                  <c:v>-42.197</c:v>
                 </c:pt>
                 <c:pt idx="3">
-                  <c:v>-37.4205</c:v>
+                  <c:v>-35.956</c:v>
                 </c:pt>
                 <c:pt idx="4">
-                  <c:v>-27.2961</c:v>
+                  <c:v>-38.8407</c:v>
+                </c:pt>
+                <c:pt idx="5">
+                  <c:v>-34.5911</c:v>
+                </c:pt>
+                <c:pt idx="6">
+                  <c:v>-39.0078</c:v>
+                </c:pt>
+                <c:pt idx="7">
+                  <c:v>-35.9979</c:v>
+                </c:pt>
+                <c:pt idx="8">
+                  <c:v>-37.1872</c:v>
+                </c:pt>
+                <c:pt idx="9">
+                  <c:v>-36.2334</c:v>
                 </c:pt>
               </c:numCache>
             </c:numRef>
@@ -4348,13 +4560,14 @@
           <c:idx val="1"/>
           <c:order val="1"/>
           <c:tx>
-            <c:v>Seed 1</c:v>
+            <c:v>95% CI upper</c:v>
           </c:tx>
           <c:spPr>
-            <a:ln xmlns:a="http://schemas.openxmlformats.org/drawingml/2006/main" w="28575">
+            <a:ln xmlns:a="http://schemas.openxmlformats.org/drawingml/2006/main" w="15875">
               <a:solidFill>
-                <a:srgbClr val="21867A"/>
+                <a:srgbClr val="DC7841"/>
               </a:solidFill>
+              <a:prstDash val="dash"/>
             </a:ln>
           </c:spPr>
           <c:marker>
@@ -4362,23 +4575,38 @@
           </c:marker>
           <c:cat>
             <c:numRef>
-              <c:f>'Chart Data'!$C$2:$C$6</c:f>
+              <c:f>'Chart Data'!$C$2:$C$11</c:f>
               <c:numCache>
                 <c:formatCode>General</c:formatCode>
-                <c:ptCount val="5"/>
+                <c:ptCount val="10"/>
                 <c:pt idx="0">
+                  <c:v>5.12</c:v>
+                </c:pt>
+                <c:pt idx="1">
                   <c:v>10.24</c:v>
                 </c:pt>
-                <c:pt idx="1">
+                <c:pt idx="2">
+                  <c:v>15.36</c:v>
+                </c:pt>
+                <c:pt idx="3">
                   <c:v>20.48</c:v>
                 </c:pt>
-                <c:pt idx="2">
+                <c:pt idx="4">
+                  <c:v>25.6</c:v>
+                </c:pt>
+                <c:pt idx="5">
                   <c:v>30.72</c:v>
                 </c:pt>
-                <c:pt idx="3">
+                <c:pt idx="6">
+                  <c:v>35.84</c:v>
+                </c:pt>
+                <c:pt idx="7">
                   <c:v>40.96</c:v>
                 </c:pt>
-                <c:pt idx="4">
+                <c:pt idx="8">
+                  <c:v>46.08</c:v>
+                </c:pt>
+                <c:pt idx="9">
                   <c:v>50</c:v>
                 </c:pt>
               </c:numCache>
@@ -4386,24 +4614,39 @@
           </c:cat>
           <c:val>
             <c:numRef>
-              <c:f>'Chart Data'!$D$2:$D$6</c:f>
+              <c:f>'Chart Data'!$D$2:$D$11</c:f>
               <c:numCache>
-                <c:formatCode>0</c:formatCode>
-                <c:ptCount val="5"/>
+                <c:formatCode>0.0</c:formatCode>
+                <c:ptCount val="10"/>
                 <c:pt idx="0">
-                  <c:v>-44.8183</c:v>
+                  <c:v>-103.084</c:v>
                 </c:pt>
                 <c:pt idx="1">
-                  <c:v>-32.7722</c:v>
+                  <c:v>-40.1306</c:v>
                 </c:pt>
                 <c:pt idx="2">
-                  <c:v>-28.2849</c:v>
+                  <c:v>-36.0293</c:v>
                 </c:pt>
                 <c:pt idx="3">
-                  <c:v>-39.68</c:v>
+                  <c:v>-31.1726</c:v>
                 </c:pt>
                 <c:pt idx="4">
-                  <c:v>-41.2693</c:v>
+                  <c:v>-31.0118</c:v>
+                </c:pt>
+                <c:pt idx="5">
+                  <c:v>-30.9243</c:v>
+                </c:pt>
+                <c:pt idx="6">
+                  <c:v>-33.4898</c:v>
+                </c:pt>
+                <c:pt idx="7">
+                  <c:v>-33.2568</c:v>
+                </c:pt>
+                <c:pt idx="8">
+                  <c:v>-34.2242</c:v>
+                </c:pt>
+                <c:pt idx="9">
+                  <c:v>-33.0609</c:v>
                 </c:pt>
               </c:numCache>
             </c:numRef>
@@ -4414,13 +4657,14 @@
           <c:idx val="2"/>
           <c:order val="2"/>
           <c:tx>
-            <c:v>Seed 2</c:v>
+            <c:v>95% CI lower</c:v>
           </c:tx>
           <c:spPr>
-            <a:ln xmlns:a="http://schemas.openxmlformats.org/drawingml/2006/main" w="28575">
+            <a:ln xmlns:a="http://schemas.openxmlformats.org/drawingml/2006/main" w="15875">
               <a:solidFill>
                 <a:srgbClr val="DC7841"/>
               </a:solidFill>
+              <a:prstDash val="dash"/>
             </a:ln>
           </c:spPr>
           <c:marker>
@@ -4428,23 +4672,38 @@
           </c:marker>
           <c:cat>
             <c:numRef>
-              <c:f>'Chart Data'!$E$2:$E$6</c:f>
+              <c:f>'Chart Data'!$E$2:$E$11</c:f>
               <c:numCache>
                 <c:formatCode>General</c:formatCode>
-                <c:ptCount val="5"/>
+                <c:ptCount val="10"/>
                 <c:pt idx="0">
+                  <c:v>5.12</c:v>
+                </c:pt>
+                <c:pt idx="1">
                   <c:v>10.24</c:v>
                 </c:pt>
-                <c:pt idx="1">
+                <c:pt idx="2">
+                  <c:v>15.36</c:v>
+                </c:pt>
+                <c:pt idx="3">
                   <c:v>20.48</c:v>
                 </c:pt>
-                <c:pt idx="2">
+                <c:pt idx="4">
+                  <c:v>25.6</c:v>
+                </c:pt>
+                <c:pt idx="5">
                   <c:v>30.72</c:v>
                 </c:pt>
-                <c:pt idx="3">
+                <c:pt idx="6">
+                  <c:v>35.84</c:v>
+                </c:pt>
+                <c:pt idx="7">
                   <c:v>40.96</c:v>
                 </c:pt>
-                <c:pt idx="4">
+                <c:pt idx="8">
+                  <c:v>46.08</c:v>
+                </c:pt>
+                <c:pt idx="9">
                   <c:v>50</c:v>
                 </c:pt>
               </c:numCache>
@@ -4452,156 +4711,39 @@
           </c:cat>
           <c:val>
             <c:numRef>
-              <c:f>'Chart Data'!$F$2:$F$6</c:f>
+              <c:f>'Chart Data'!$F$2:$F$11</c:f>
               <c:numCache>
-                <c:formatCode>0</c:formatCode>
-                <c:ptCount val="5"/>
+                <c:formatCode>0.0</c:formatCode>
+                <c:ptCount val="10"/>
                 <c:pt idx="0">
-                  <c:v>-35.223</c:v>
+                  <c:v>-131.513</c:v>
                 </c:pt>
                 <c:pt idx="1">
-                  <c:v>-23.8927</c:v>
+                  <c:v>-55.7836</c:v>
                 </c:pt>
                 <c:pt idx="2">
-                  <c:v>-40.9444</c:v>
+                  <c:v>-48.3648</c:v>
                 </c:pt>
                 <c:pt idx="3">
-                  <c:v>-35.6409</c:v>
+                  <c:v>-40.7395</c:v>
                 </c:pt>
                 <c:pt idx="4">
-                  <c:v>-38.4033</c:v>
+                  <c:v>-46.6696</c:v>
                 </c:pt>
-              </c:numCache>
-            </c:numRef>
-          </c:val>
-          <c:smooth val="0"/>
-        </c:ser>
-        <c:ser>
-          <c:idx val="3"/>
-          <c:order val="3"/>
-          <c:tx>
-            <c:v>Seed 3</c:v>
-          </c:tx>
-          <c:spPr>
-            <a:ln xmlns:a="http://schemas.openxmlformats.org/drawingml/2006/main" w="28575">
-              <a:solidFill>
-                <a:srgbClr val="7C61A8"/>
-              </a:solidFill>
-            </a:ln>
-          </c:spPr>
-          <c:marker>
-            <c:symbol val="none"/>
-          </c:marker>
-          <c:cat>
-            <c:numRef>
-              <c:f>'Chart Data'!$G$2:$G$6</c:f>
-              <c:numCache>
-                <c:formatCode>General</c:formatCode>
-                <c:ptCount val="5"/>
-                <c:pt idx="0">
-                  <c:v>10.24</c:v>
+                <c:pt idx="5">
+                  <c:v>-38.2579</c:v>
                 </c:pt>
-                <c:pt idx="1">
-                  <c:v>20.48</c:v>
+                <c:pt idx="6">
+                  <c:v>-44.5258</c:v>
                 </c:pt>
-                <c:pt idx="2">
-                  <c:v>30.72</c:v>
+                <c:pt idx="7">
+                  <c:v>-38.739</c:v>
                 </c:pt>
-                <c:pt idx="3">
-                  <c:v>40.96</c:v>
+                <c:pt idx="8">
+                  <c:v>-40.1502</c:v>
                 </c:pt>
-                <c:pt idx="4">
-                  <c:v>50</c:v>
-                </c:pt>
-              </c:numCache>
-            </c:numRef>
-          </c:cat>
-          <c:val>
-            <c:numRef>
-              <c:f>'Chart Data'!$H$2:$H$6</c:f>
-              <c:numCache>
-                <c:formatCode>0</c:formatCode>
-                <c:ptCount val="5"/>
-                <c:pt idx="0">
-                  <c:v>-51.3357</c:v>
-                </c:pt>
-                <c:pt idx="1">
-                  <c:v>-31.4364</c:v>
-                </c:pt>
-                <c:pt idx="2">
-                  <c:v>-33.6457</c:v>
-                </c:pt>
-                <c:pt idx="3">
-                  <c:v>-36.0628</c:v>
-                </c:pt>
-                <c:pt idx="4">
-                  <c:v>-42.1837</c:v>
-                </c:pt>
-              </c:numCache>
-            </c:numRef>
-          </c:val>
-          <c:smooth val="0"/>
-        </c:ser>
-        <c:ser>
-          <c:idx val="4"/>
-          <c:order val="4"/>
-          <c:tx>
-            <c:v>Seed 4</c:v>
-          </c:tx>
-          <c:spPr>
-            <a:ln xmlns:a="http://schemas.openxmlformats.org/drawingml/2006/main" w="28575">
-              <a:solidFill>
-                <a:srgbClr val="8B8C45"/>
-              </a:solidFill>
-            </a:ln>
-          </c:spPr>
-          <c:marker>
-            <c:symbol val="none"/>
-          </c:marker>
-          <c:cat>
-            <c:numRef>
-              <c:f>'Chart Data'!$I$2:$I$6</c:f>
-              <c:numCache>
-                <c:formatCode>General</c:formatCode>
-                <c:ptCount val="5"/>
-                <c:pt idx="0">
-                  <c:v>10.24</c:v>
-                </c:pt>
-                <c:pt idx="1">
-                  <c:v>20.48</c:v>
-                </c:pt>
-                <c:pt idx="2">
-                  <c:v>30.72</c:v>
-                </c:pt>
-                <c:pt idx="3">
-                  <c:v>40.96</c:v>
-                </c:pt>
-                <c:pt idx="4">
-                  <c:v>50</c:v>
-                </c:pt>
-              </c:numCache>
-            </c:numRef>
-          </c:cat>
-          <c:val>
-            <c:numRef>
-              <c:f>'Chart Data'!$J$2:$J$6</c:f>
-              <c:numCache>
-                <c:formatCode>0</c:formatCode>
-                <c:ptCount val="5"/>
-                <c:pt idx="0">
-                  <c:v>-43.7454</c:v>
-                </c:pt>
-                <c:pt idx="1">
-                  <c:v>-41.9732</c:v>
-                </c:pt>
-                <c:pt idx="2">
-                  <c:v>-37.9099</c:v>
-                </c:pt>
-                <c:pt idx="3">
-                  <c:v>-36.8569</c:v>
-                </c:pt>
-                <c:pt idx="4">
-                  <c:v>-35.4941</c:v>
+                <c:pt idx="9">
+                  <c:v>-39.4059</c:v>
                 </c:pt>
               </c:numCache>
             </c:numRef>
@@ -4682,6 +4824,7 @@
         <c:numFmt formatCode="General"/>
         <c:majorTickMark val="none"/>
         <c:minorTickMark val="none"/>
+        <c:tickLblPos val="low"/>
         <c:spPr>
           <a:ln xmlns:a="http://schemas.openxmlformats.org/drawingml/2006/main" w="9525">
             <a:solidFill>
@@ -4922,7 +5065,7 @@
                   <c:v>15905</c:v>
                 </c:pt>
                 <c:pt idx="2">
-                  <c:v>17599.6733</c:v>
+                  <c:v>17648.8</c:v>
                 </c:pt>
               </c:numCache>
             </c:numRef>
@@ -5151,7 +5294,7 @@
                   <c:v>6.5908</c:v>
                 </c:pt>
                 <c:pt idx="2">
-                  <c:v>2.5013</c:v>
+                  <c:v>2.20633</c:v>
                 </c:pt>
               </c:numCache>
             </c:numRef>
@@ -5468,13 +5611,13 @@
                 <c:formatCode>0.0</c:formatCode>
                 <c:ptCount val="3"/>
                 <c:pt idx="0">
-                  <c:v>5.0546</c:v>
+                  <c:v>4.177</c:v>
                 </c:pt>
                 <c:pt idx="1">
-                  <c:v>2.3899</c:v>
+                  <c:v>2.37798</c:v>
                 </c:pt>
                 <c:pt idx="2">
-                  <c:v>0.0593</c:v>
+                  <c:v>0.0639991</c:v>
                 </c:pt>
               </c:numCache>
             </c:numRef>
@@ -5667,6 +5810,1120 @@
 </c:chartSpace>
 </file>
 
+<file path=ppt/slides/charts/chart5.xml><?xml version="1.0" encoding="utf-8"?>
+<c:chartSpace xmlns:c="http://schemas.openxmlformats.org/drawingml/2006/chart" xmlns:r="http://schemas.openxmlformats.org/officeDocument/2006/relationships">
+  <c:lang val="en-US"/>
+  <c:chart>
+    <c:title>
+      <c:tx>
+        <c:rich>
+          <a:bodyPr xmlns:a="http://schemas.openxmlformats.org/drawingml/2006/main"/>
+          <a:lstStyle xmlns:a="http://schemas.openxmlformats.org/drawingml/2006/main"/>
+          <a:p xmlns:a="http://schemas.openxmlformats.org/drawingml/2006/main">
+            <a:r>
+              <a:rPr sz="1725">
+                <a:solidFill>
+                  <a:srgbClr val="172D44"/>
+                </a:solidFill>
+                <a:latin typeface="DejaVu Sans"/>
+                <a:ea typeface="DejaVu Sans"/>
+                <a:cs typeface="DejaVu Sans"/>
+              </a:rPr>
+              <a:t>Decisions to threshold (thousands)</a:t>
+            </a:r>
+          </a:p>
+        </c:rich>
+      </c:tx>
+      <c:overlay val="0"/>
+      <c:txPr>
+        <a:bodyPr xmlns:a="http://schemas.openxmlformats.org/drawingml/2006/main" anchorCtr="1"/>
+        <a:lstStyle xmlns:a="http://schemas.openxmlformats.org/drawingml/2006/main"/>
+        <a:p xmlns:a="http://schemas.openxmlformats.org/drawingml/2006/main">
+          <a:pPr>
+            <a:defRPr sz="1725">
+              <a:solidFill>
+                <a:srgbClr val="172D44"/>
+              </a:solidFill>
+              <a:latin typeface="DejaVu Sans"/>
+              <a:ea typeface="DejaVu Sans"/>
+              <a:cs typeface="DejaVu Sans"/>
+            </a:defRPr>
+          </a:pPr>
+        </a:p>
+      </c:txPr>
+    </c:title>
+    <c:plotArea>
+      <c:barChart>
+        <c:barDir val="col"/>
+        <c:grouping val="clustered"/>
+        <c:varyColors val="0"/>
+        <c:ser>
+          <c:idx val="0"/>
+          <c:order val="0"/>
+          <c:tx>
+            <c:v>Decisions (k)</c:v>
+          </c:tx>
+          <c:spPr>
+            <a:solidFill xmlns:a="http://schemas.openxmlformats.org/drawingml/2006/main">
+              <a:srgbClr val="172D44"/>
+            </a:solidFill>
+          </c:spPr>
+          <c:invertIfNegative val="0"/>
+          <c:dPt>
+            <c:idx val="0"/>
+            <c:invertIfNegative val="0"/>
+            <c:bubble3D val="0"/>
+            <c:spPr>
+              <a:solidFill xmlns:a="http://schemas.openxmlformats.org/drawingml/2006/main">
+                <a:srgbClr val="DC7841"/>
+              </a:solidFill>
+            </c:spPr>
+          </c:dPt>
+          <c:dPt>
+            <c:idx val="1"/>
+            <c:invertIfNegative val="0"/>
+            <c:bubble3D val="0"/>
+            <c:spPr>
+              <a:solidFill xmlns:a="http://schemas.openxmlformats.org/drawingml/2006/main">
+                <a:srgbClr val="172D44"/>
+              </a:solidFill>
+            </c:spPr>
+          </c:dPt>
+          <c:dPt>
+            <c:idx val="2"/>
+            <c:invertIfNegative val="0"/>
+            <c:bubble3D val="0"/>
+            <c:spPr>
+              <a:solidFill xmlns:a="http://schemas.openxmlformats.org/drawingml/2006/main">
+                <a:srgbClr val="21867A"/>
+              </a:solidFill>
+            </c:spPr>
+          </c:dPt>
+          <c:dPt>
+            <c:idx val="3"/>
+            <c:invertIfNegative val="0"/>
+            <c:bubble3D val="0"/>
+            <c:spPr>
+              <a:solidFill xmlns:a="http://schemas.openxmlformats.org/drawingml/2006/main">
+                <a:srgbClr val="8993A0"/>
+              </a:solidFill>
+            </c:spPr>
+          </c:dPt>
+          <c:cat>
+            <c:strRef>
+              <c:f>'Chart Data'!$A$2:$A$5</c:f>
+              <c:strCache>
+                <c:ptCount val="4"/>
+                <c:pt idx="0">
+                  <c:v>Full PPO</c:v>
+                </c:pt>
+                <c:pt idx="1">
+                  <c:v>No clip</c:v>
+                </c:pt>
+                <c:pt idx="2">
+                  <c:v>λ = 1</c:v>
+                </c:pt>
+                <c:pt idx="3">
+                  <c:v>λ = 0</c:v>
+                </c:pt>
+              </c:strCache>
+            </c:strRef>
+          </c:cat>
+          <c:val>
+            <c:numRef>
+              <c:f>'Chart Data'!$B$2:$B$5</c:f>
+              <c:numCache>
+                <c:formatCode>0.0</c:formatCode>
+                <c:ptCount val="4"/>
+                <c:pt idx="0">
+                  <c:v>6.4512</c:v>
+                </c:pt>
+                <c:pt idx="1">
+                  <c:v>5.4272</c:v>
+                </c:pt>
+                <c:pt idx="2">
+                  <c:v>6.656</c:v>
+                </c:pt>
+                <c:pt idx="3">
+                  <c:v>9.3184</c:v>
+                </c:pt>
+              </c:numCache>
+            </c:numRef>
+          </c:val>
+        </c:ser>
+        <c:dLbls>
+          <c:numFmt formatCode="0.0" sourceLinked="0"/>
+          <c:txPr>
+            <a:bodyPr xmlns:a="http://schemas.openxmlformats.org/drawingml/2006/main" anchorCtr="1"/>
+            <a:lstStyle xmlns:a="http://schemas.openxmlformats.org/drawingml/2006/main"/>
+            <a:p xmlns:a="http://schemas.openxmlformats.org/drawingml/2006/main">
+              <a:pPr>
+                <a:defRPr sz="1575">
+                  <a:solidFill>
+                    <a:srgbClr val="263A4E"/>
+                  </a:solidFill>
+                  <a:latin typeface="DejaVu Sans"/>
+                  <a:ea typeface="DejaVu Sans"/>
+                  <a:cs typeface="DejaVu Sans"/>
+                </a:defRPr>
+              </a:pPr>
+            </a:p>
+          </c:txPr>
+          <c:dLblPos val="outEnd"/>
+          <c:showLegendKey val="0"/>
+          <c:showVal val="1"/>
+          <c:showCatName val="0"/>
+          <c:showSerName val="0"/>
+          <c:showPercent val="0"/>
+          <c:showBubbleSize val="0"/>
+          <c:showLeaderLines val="0"/>
+        </c:dLbls>
+        <c:gapWidth val="95"/>
+        <c:axId val="48650112"/>
+        <c:axId val="48672768"/>
+      </c:barChart>
+      <c:catAx>
+        <c:axId val="48650112"/>
+        <c:scaling>
+          <c:orientation val="minMax"/>
+        </c:scaling>
+        <c:delete val="0"/>
+        <c:axPos val="b"/>
+        <c:numFmt formatCode="General"/>
+        <c:majorTickMark val="none"/>
+        <c:minorTickMark val="none"/>
+        <c:spPr>
+          <a:ln xmlns:a="http://schemas.openxmlformats.org/drawingml/2006/main" w="9525">
+            <a:solidFill>
+              <a:srgbClr val="D4D4D4"/>
+            </a:solidFill>
+            <a:prstDash val="solid"/>
+          </a:ln>
+        </c:spPr>
+        <c:txPr>
+          <a:bodyPr xmlns:a="http://schemas.openxmlformats.org/drawingml/2006/main" anchorCtr="1"/>
+          <a:lstStyle xmlns:a="http://schemas.openxmlformats.org/drawingml/2006/main"/>
+          <a:p xmlns:a="http://schemas.openxmlformats.org/drawingml/2006/main">
+            <a:pPr>
+              <a:defRPr sz="1575">
+                <a:solidFill>
+                  <a:srgbClr val="263A4E"/>
+                </a:solidFill>
+                <a:latin typeface="DejaVu Sans"/>
+                <a:ea typeface="DejaVu Sans"/>
+                <a:cs typeface="DejaVu Sans"/>
+              </a:defRPr>
+            </a:pPr>
+          </a:p>
+        </c:txPr>
+        <c:crossAx val="48672768"/>
+      </c:catAx>
+      <c:valAx>
+        <c:axId val="48672768"/>
+        <c:scaling>
+          <c:orientation val="minMax"/>
+        </c:scaling>
+        <c:delete val="0"/>
+        <c:axPos val="l"/>
+        <c:majorGridlines>
+          <c:spPr>
+            <a:ln xmlns:a="http://schemas.openxmlformats.org/drawingml/2006/main" w="9525">
+              <a:solidFill>
+                <a:srgbClr val="DCE3E9"/>
+              </a:solidFill>
+            </a:ln>
+          </c:spPr>
+        </c:majorGridlines>
+        <c:numFmt formatCode="0.0"/>
+        <c:majorTickMark val="none"/>
+        <c:minorTickMark val="none"/>
+        <c:spPr>
+          <a:ln xmlns:a="http://schemas.openxmlformats.org/drawingml/2006/main" w="9525">
+            <a:solidFill>
+              <a:srgbClr val="D4D4D4"/>
+            </a:solidFill>
+            <a:prstDash val="solid"/>
+          </a:ln>
+        </c:spPr>
+        <c:txPr>
+          <a:bodyPr xmlns:a="http://schemas.openxmlformats.org/drawingml/2006/main" anchorCtr="1"/>
+          <a:lstStyle xmlns:a="http://schemas.openxmlformats.org/drawingml/2006/main"/>
+          <a:p xmlns:a="http://schemas.openxmlformats.org/drawingml/2006/main">
+            <a:pPr>
+              <a:defRPr sz="1575">
+                <a:solidFill>
+                  <a:srgbClr val="263A4E"/>
+                </a:solidFill>
+                <a:latin typeface="DejaVu Sans"/>
+                <a:ea typeface="DejaVu Sans"/>
+                <a:cs typeface="DejaVu Sans"/>
+              </a:defRPr>
+            </a:pPr>
+          </a:p>
+        </c:txPr>
+        <c:crossAx val="48650112"/>
+        <c:crossBetween val="between"/>
+      </c:valAx>
+      <c:spPr>
+        <a:solidFill xmlns:a="http://schemas.openxmlformats.org/drawingml/2006/main">
+          <a:srgbClr val="FFFFFF"/>
+        </a:solidFill>
+      </c:spPr>
+    </c:plotArea>
+    <c:plotVisOnly val="1"/>
+  </c:chart>
+  <c:spPr>
+    <a:solidFill xmlns:a="http://schemas.openxmlformats.org/drawingml/2006/main">
+      <a:srgbClr val="FFFFFF"/>
+    </a:solidFill>
+    <a:ln xmlns:a="http://schemas.openxmlformats.org/drawingml/2006/main" w="0">
+      <a:noFill/>
+    </a:ln>
+  </c:spPr>
+  <c:externalData r:id="rIdChartSnapshot1">
+    <c:autoUpdate val="0"/>
+  </c:externalData>
+</c:chartSpace>
+</file>
+
+<file path=ppt/slides/charts/chart6.xml><?xml version="1.0" encoding="utf-8"?>
+<c:chartSpace xmlns:c="http://schemas.openxmlformats.org/drawingml/2006/chart" xmlns:r="http://schemas.openxmlformats.org/officeDocument/2006/relationships">
+  <c:lang val="en-US"/>
+  <c:chart>
+    <c:title>
+      <c:tx>
+        <c:rich>
+          <a:bodyPr xmlns:a="http://schemas.openxmlformats.org/drawingml/2006/main"/>
+          <a:lstStyle xmlns:a="http://schemas.openxmlformats.org/drawingml/2006/main"/>
+          <a:p xmlns:a="http://schemas.openxmlformats.org/drawingml/2006/main">
+            <a:r>
+              <a:rPr sz="1725">
+                <a:solidFill>
+                  <a:srgbClr val="172D44"/>
+                </a:solidFill>
+                <a:latin typeface="DejaVu Sans"/>
+                <a:ea typeface="DejaVu Sans"/>
+                <a:cs typeface="DejaVu Sans"/>
+              </a:rPr>
+              <a:t>Largest update KL per run (mean)</a:t>
+            </a:r>
+          </a:p>
+        </c:rich>
+      </c:tx>
+      <c:overlay val="0"/>
+      <c:txPr>
+        <a:bodyPr xmlns:a="http://schemas.openxmlformats.org/drawingml/2006/main" anchorCtr="1"/>
+        <a:lstStyle xmlns:a="http://schemas.openxmlformats.org/drawingml/2006/main"/>
+        <a:p xmlns:a="http://schemas.openxmlformats.org/drawingml/2006/main">
+          <a:pPr>
+            <a:defRPr sz="1725">
+              <a:solidFill>
+                <a:srgbClr val="172D44"/>
+              </a:solidFill>
+              <a:latin typeface="DejaVu Sans"/>
+              <a:ea typeface="DejaVu Sans"/>
+              <a:cs typeface="DejaVu Sans"/>
+            </a:defRPr>
+          </a:pPr>
+        </a:p>
+      </c:txPr>
+    </c:title>
+    <c:plotArea>
+      <c:barChart>
+        <c:barDir val="col"/>
+        <c:grouping val="clustered"/>
+        <c:varyColors val="0"/>
+        <c:ser>
+          <c:idx val="0"/>
+          <c:order val="0"/>
+          <c:tx>
+            <c:v>Max KL</c:v>
+          </c:tx>
+          <c:spPr>
+            <a:solidFill xmlns:a="http://schemas.openxmlformats.org/drawingml/2006/main">
+              <a:srgbClr val="DC7841"/>
+            </a:solidFill>
+          </c:spPr>
+          <c:invertIfNegative val="0"/>
+          <c:dPt>
+            <c:idx val="0"/>
+            <c:invertIfNegative val="0"/>
+            <c:bubble3D val="0"/>
+            <c:spPr>
+              <a:solidFill xmlns:a="http://schemas.openxmlformats.org/drawingml/2006/main">
+                <a:srgbClr val="DC7841"/>
+              </a:solidFill>
+            </c:spPr>
+          </c:dPt>
+          <c:dPt>
+            <c:idx val="1"/>
+            <c:invertIfNegative val="0"/>
+            <c:bubble3D val="0"/>
+            <c:spPr>
+              <a:solidFill xmlns:a="http://schemas.openxmlformats.org/drawingml/2006/main">
+                <a:srgbClr val="172D44"/>
+              </a:solidFill>
+            </c:spPr>
+          </c:dPt>
+          <c:dPt>
+            <c:idx val="2"/>
+            <c:invertIfNegative val="0"/>
+            <c:bubble3D val="0"/>
+            <c:spPr>
+              <a:solidFill xmlns:a="http://schemas.openxmlformats.org/drawingml/2006/main">
+                <a:srgbClr val="21867A"/>
+              </a:solidFill>
+            </c:spPr>
+          </c:dPt>
+          <c:dPt>
+            <c:idx val="3"/>
+            <c:invertIfNegative val="0"/>
+            <c:bubble3D val="0"/>
+            <c:spPr>
+              <a:solidFill xmlns:a="http://schemas.openxmlformats.org/drawingml/2006/main">
+                <a:srgbClr val="8993A0"/>
+              </a:solidFill>
+            </c:spPr>
+          </c:dPt>
+          <c:cat>
+            <c:strRef>
+              <c:f>'Chart Data'!$A$2:$A$5</c:f>
+              <c:strCache>
+                <c:ptCount val="4"/>
+                <c:pt idx="0">
+                  <c:v>Full PPO</c:v>
+                </c:pt>
+                <c:pt idx="1">
+                  <c:v>No clip</c:v>
+                </c:pt>
+                <c:pt idx="2">
+                  <c:v>λ = 1</c:v>
+                </c:pt>
+                <c:pt idx="3">
+                  <c:v>λ = 0</c:v>
+                </c:pt>
+              </c:strCache>
+            </c:strRef>
+          </c:cat>
+          <c:val>
+            <c:numRef>
+              <c:f>'Chart Data'!$B$2:$B$5</c:f>
+              <c:numCache>
+                <c:formatCode>0.000</c:formatCode>
+                <c:ptCount val="4"/>
+                <c:pt idx="0">
+                  <c:v>0.015184</c:v>
+                </c:pt>
+                <c:pt idx="1">
+                  <c:v>0.599784</c:v>
+                </c:pt>
+                <c:pt idx="2">
+                  <c:v>0.0130538</c:v>
+                </c:pt>
+                <c:pt idx="3">
+                  <c:v>0.0299532</c:v>
+                </c:pt>
+              </c:numCache>
+            </c:numRef>
+          </c:val>
+        </c:ser>
+        <c:dLbls>
+          <c:numFmt formatCode="0.000" sourceLinked="0"/>
+          <c:txPr>
+            <a:bodyPr xmlns:a="http://schemas.openxmlformats.org/drawingml/2006/main" anchorCtr="1"/>
+            <a:lstStyle xmlns:a="http://schemas.openxmlformats.org/drawingml/2006/main"/>
+            <a:p xmlns:a="http://schemas.openxmlformats.org/drawingml/2006/main">
+              <a:pPr>
+                <a:defRPr sz="1575">
+                  <a:solidFill>
+                    <a:srgbClr val="263A4E"/>
+                  </a:solidFill>
+                  <a:latin typeface="DejaVu Sans"/>
+                  <a:ea typeface="DejaVu Sans"/>
+                  <a:cs typeface="DejaVu Sans"/>
+                </a:defRPr>
+              </a:pPr>
+            </a:p>
+          </c:txPr>
+          <c:dLblPos val="outEnd"/>
+          <c:showLegendKey val="0"/>
+          <c:showVal val="1"/>
+          <c:showCatName val="0"/>
+          <c:showSerName val="0"/>
+          <c:showPercent val="0"/>
+          <c:showBubbleSize val="0"/>
+          <c:showLeaderLines val="0"/>
+        </c:dLbls>
+        <c:gapWidth val="95"/>
+        <c:axId val="48650112"/>
+        <c:axId val="48672768"/>
+      </c:barChart>
+      <c:catAx>
+        <c:axId val="48650112"/>
+        <c:scaling>
+          <c:orientation val="minMax"/>
+        </c:scaling>
+        <c:delete val="0"/>
+        <c:axPos val="b"/>
+        <c:numFmt formatCode="General"/>
+        <c:majorTickMark val="none"/>
+        <c:minorTickMark val="none"/>
+        <c:spPr>
+          <a:ln xmlns:a="http://schemas.openxmlformats.org/drawingml/2006/main" w="9525">
+            <a:solidFill>
+              <a:srgbClr val="D4D4D4"/>
+            </a:solidFill>
+            <a:prstDash val="solid"/>
+          </a:ln>
+        </c:spPr>
+        <c:txPr>
+          <a:bodyPr xmlns:a="http://schemas.openxmlformats.org/drawingml/2006/main" anchorCtr="1"/>
+          <a:lstStyle xmlns:a="http://schemas.openxmlformats.org/drawingml/2006/main"/>
+          <a:p xmlns:a="http://schemas.openxmlformats.org/drawingml/2006/main">
+            <a:pPr>
+              <a:defRPr sz="1575">
+                <a:solidFill>
+                  <a:srgbClr val="263A4E"/>
+                </a:solidFill>
+                <a:latin typeface="DejaVu Sans"/>
+                <a:ea typeface="DejaVu Sans"/>
+                <a:cs typeface="DejaVu Sans"/>
+              </a:defRPr>
+            </a:pPr>
+          </a:p>
+        </c:txPr>
+        <c:crossAx val="48672768"/>
+      </c:catAx>
+      <c:valAx>
+        <c:axId val="48672768"/>
+        <c:scaling>
+          <c:orientation val="minMax"/>
+        </c:scaling>
+        <c:delete val="0"/>
+        <c:axPos val="l"/>
+        <c:majorGridlines>
+          <c:spPr>
+            <a:ln xmlns:a="http://schemas.openxmlformats.org/drawingml/2006/main" w="9525">
+              <a:solidFill>
+                <a:srgbClr val="DCE3E9"/>
+              </a:solidFill>
+            </a:ln>
+          </c:spPr>
+        </c:majorGridlines>
+        <c:numFmt formatCode="0.0"/>
+        <c:majorTickMark val="none"/>
+        <c:minorTickMark val="none"/>
+        <c:spPr>
+          <a:ln xmlns:a="http://schemas.openxmlformats.org/drawingml/2006/main" w="9525">
+            <a:solidFill>
+              <a:srgbClr val="D4D4D4"/>
+            </a:solidFill>
+            <a:prstDash val="solid"/>
+          </a:ln>
+        </c:spPr>
+        <c:txPr>
+          <a:bodyPr xmlns:a="http://schemas.openxmlformats.org/drawingml/2006/main" anchorCtr="1"/>
+          <a:lstStyle xmlns:a="http://schemas.openxmlformats.org/drawingml/2006/main"/>
+          <a:p xmlns:a="http://schemas.openxmlformats.org/drawingml/2006/main">
+            <a:pPr>
+              <a:defRPr sz="1575">
+                <a:solidFill>
+                  <a:srgbClr val="263A4E"/>
+                </a:solidFill>
+                <a:latin typeface="DejaVu Sans"/>
+                <a:ea typeface="DejaVu Sans"/>
+                <a:cs typeface="DejaVu Sans"/>
+              </a:defRPr>
+            </a:pPr>
+          </a:p>
+        </c:txPr>
+        <c:crossAx val="48650112"/>
+        <c:crossBetween val="between"/>
+      </c:valAx>
+      <c:spPr>
+        <a:solidFill xmlns:a="http://schemas.openxmlformats.org/drawingml/2006/main">
+          <a:srgbClr val="FFFFFF"/>
+        </a:solidFill>
+      </c:spPr>
+    </c:plotArea>
+    <c:plotVisOnly val="1"/>
+  </c:chart>
+  <c:spPr>
+    <a:solidFill xmlns:a="http://schemas.openxmlformats.org/drawingml/2006/main">
+      <a:srgbClr val="FFFFFF"/>
+    </a:solidFill>
+    <a:ln xmlns:a="http://schemas.openxmlformats.org/drawingml/2006/main" w="0">
+      <a:noFill/>
+    </a:ln>
+  </c:spPr>
+  <c:externalData r:id="rIdChartSnapshot1">
+    <c:autoUpdate val="0"/>
+  </c:externalData>
+</c:chartSpace>
+</file>
+
+<file path=ppt/slides/charts/chart7.xml><?xml version="1.0" encoding="utf-8"?>
+<c:chartSpace xmlns:c="http://schemas.openxmlformats.org/drawingml/2006/chart" xmlns:r="http://schemas.openxmlformats.org/officeDocument/2006/relationships">
+  <c:lang val="en-US"/>
+  <c:chart>
+    <c:title>
+      <c:tx>
+        <c:rich>
+          <a:bodyPr xmlns:a="http://schemas.openxmlformats.org/drawingml/2006/main"/>
+          <a:lstStyle xmlns:a="http://schemas.openxmlformats.org/drawingml/2006/main"/>
+          <a:p xmlns:a="http://schemas.openxmlformats.org/drawingml/2006/main">
+            <a:r>
+              <a:rPr sz="1875">
+                <a:solidFill>
+                  <a:srgbClr val="172D44"/>
+                </a:solidFill>
+                <a:latin typeface="DejaVu Sans"/>
+                <a:ea typeface="DejaVu Sans"/>
+                <a:cs typeface="DejaVu Sans"/>
+              </a:rPr>
+              <a:t>Entropy and rejected-action probability (mean of 10 seeds)</a:t>
+            </a:r>
+          </a:p>
+        </c:rich>
+      </c:tx>
+      <c:overlay val="0"/>
+      <c:txPr>
+        <a:bodyPr xmlns:a="http://schemas.openxmlformats.org/drawingml/2006/main" anchorCtr="1"/>
+        <a:lstStyle xmlns:a="http://schemas.openxmlformats.org/drawingml/2006/main"/>
+        <a:p xmlns:a="http://schemas.openxmlformats.org/drawingml/2006/main">
+          <a:pPr>
+            <a:defRPr sz="1875">
+              <a:solidFill>
+                <a:srgbClr val="172D44"/>
+              </a:solidFill>
+              <a:latin typeface="DejaVu Sans"/>
+              <a:ea typeface="DejaVu Sans"/>
+              <a:cs typeface="DejaVu Sans"/>
+            </a:defRPr>
+          </a:pPr>
+        </a:p>
+      </c:txPr>
+    </c:title>
+    <c:plotArea>
+      <c:lineChart>
+        <c:grouping val="standard"/>
+        <c:varyColors val="0"/>
+        <c:ser>
+          <c:idx val="0"/>
+          <c:order val="0"/>
+          <c:tx>
+            <c:v>Policy entropy (nats)</c:v>
+          </c:tx>
+          <c:spPr>
+            <a:ln xmlns:a="http://schemas.openxmlformats.org/drawingml/2006/main" w="34925">
+              <a:solidFill>
+                <a:srgbClr val="DC7841"/>
+              </a:solidFill>
+            </a:ln>
+          </c:spPr>
+          <c:marker>
+            <c:symbol val="none"/>
+          </c:marker>
+          <c:cat>
+            <c:numRef>
+              <c:f>'Chart Data'!$A$2:$A$11</c:f>
+              <c:numCache>
+                <c:formatCode>General</c:formatCode>
+                <c:ptCount val="10"/>
+                <c:pt idx="0">
+                  <c:v>5.12</c:v>
+                </c:pt>
+                <c:pt idx="1">
+                  <c:v>10.24</c:v>
+                </c:pt>
+                <c:pt idx="2">
+                  <c:v>15.36</c:v>
+                </c:pt>
+                <c:pt idx="3">
+                  <c:v>20.48</c:v>
+                </c:pt>
+                <c:pt idx="4">
+                  <c:v>25.6</c:v>
+                </c:pt>
+                <c:pt idx="5">
+                  <c:v>30.72</c:v>
+                </c:pt>
+                <c:pt idx="6">
+                  <c:v>35.84</c:v>
+                </c:pt>
+                <c:pt idx="7">
+                  <c:v>40.96</c:v>
+                </c:pt>
+                <c:pt idx="8">
+                  <c:v>46.08</c:v>
+                </c:pt>
+                <c:pt idx="9">
+                  <c:v>50</c:v>
+                </c:pt>
+              </c:numCache>
+            </c:numRef>
+          </c:cat>
+          <c:val>
+            <c:numRef>
+              <c:f>'Chart Data'!$B$2:$B$11</c:f>
+              <c:numCache>
+                <c:formatCode>0.00</c:formatCode>
+                <c:ptCount val="10"/>
+                <c:pt idx="0">
+                  <c:v>0.945532</c:v>
+                </c:pt>
+                <c:pt idx="1">
+                  <c:v>0.692124</c:v>
+                </c:pt>
+                <c:pt idx="2">
+                  <c:v>0.566596</c:v>
+                </c:pt>
+                <c:pt idx="3">
+                  <c:v>0.540366</c:v>
+                </c:pt>
+                <c:pt idx="4">
+                  <c:v>0.544712</c:v>
+                </c:pt>
+                <c:pt idx="5">
+                  <c:v>0.569308</c:v>
+                </c:pt>
+                <c:pt idx="6">
+                  <c:v>0.575833</c:v>
+                </c:pt>
+                <c:pt idx="7">
+                  <c:v>0.592508</c:v>
+                </c:pt>
+                <c:pt idx="8">
+                  <c:v>0.600302</c:v>
+                </c:pt>
+                <c:pt idx="9">
+                  <c:v>0.644747</c:v>
+                </c:pt>
+              </c:numCache>
+            </c:numRef>
+          </c:val>
+          <c:smooth val="0"/>
+        </c:ser>
+        <c:ser>
+          <c:idx val="1"/>
+          <c:order val="1"/>
+          <c:tx>
+            <c:v>Executed-action entropy (nats)</c:v>
+          </c:tx>
+          <c:spPr>
+            <a:ln xmlns:a="http://schemas.openxmlformats.org/drawingml/2006/main" w="34925">
+              <a:solidFill>
+                <a:srgbClr val="21867A"/>
+              </a:solidFill>
+            </a:ln>
+          </c:spPr>
+          <c:marker>
+            <c:symbol val="none"/>
+          </c:marker>
+          <c:cat>
+            <c:numRef>
+              <c:f>'Chart Data'!$C$2:$C$11</c:f>
+              <c:numCache>
+                <c:formatCode>General</c:formatCode>
+                <c:ptCount val="10"/>
+                <c:pt idx="0">
+                  <c:v>5.12</c:v>
+                </c:pt>
+                <c:pt idx="1">
+                  <c:v>10.24</c:v>
+                </c:pt>
+                <c:pt idx="2">
+                  <c:v>15.36</c:v>
+                </c:pt>
+                <c:pt idx="3">
+                  <c:v>20.48</c:v>
+                </c:pt>
+                <c:pt idx="4">
+                  <c:v>25.6</c:v>
+                </c:pt>
+                <c:pt idx="5">
+                  <c:v>30.72</c:v>
+                </c:pt>
+                <c:pt idx="6">
+                  <c:v>35.84</c:v>
+                </c:pt>
+                <c:pt idx="7">
+                  <c:v>40.96</c:v>
+                </c:pt>
+                <c:pt idx="8">
+                  <c:v>46.08</c:v>
+                </c:pt>
+                <c:pt idx="9">
+                  <c:v>50</c:v>
+                </c:pt>
+              </c:numCache>
+            </c:numRef>
+          </c:cat>
+          <c:val>
+            <c:numRef>
+              <c:f>'Chart Data'!$D$2:$D$11</c:f>
+              <c:numCache>
+                <c:formatCode>0.00</c:formatCode>
+                <c:ptCount val="10"/>
+                <c:pt idx="0">
+                  <c:v>0.603317</c:v>
+                </c:pt>
+                <c:pt idx="1">
+                  <c:v>0.297042</c:v>
+                </c:pt>
+                <c:pt idx="2">
+                  <c:v>0.202936</c:v>
+                </c:pt>
+                <c:pt idx="3">
+                  <c:v>0.171738</c:v>
+                </c:pt>
+                <c:pt idx="4">
+                  <c:v>0.185995</c:v>
+                </c:pt>
+                <c:pt idx="5">
+                  <c:v>0.170929</c:v>
+                </c:pt>
+                <c:pt idx="6">
+                  <c:v>0.17654</c:v>
+                </c:pt>
+                <c:pt idx="7">
+                  <c:v>0.159831</c:v>
+                </c:pt>
+                <c:pt idx="8">
+                  <c:v>0.141116</c:v>
+                </c:pt>
+                <c:pt idx="9">
+                  <c:v>0.169228</c:v>
+                </c:pt>
+              </c:numCache>
+            </c:numRef>
+          </c:val>
+          <c:smooth val="0"/>
+        </c:ser>
+        <c:ser>
+          <c:idx val="2"/>
+          <c:order val="2"/>
+          <c:tx>
+            <c:v>Probability on rejected actions</c:v>
+          </c:tx>
+          <c:spPr>
+            <a:ln xmlns:a="http://schemas.openxmlformats.org/drawingml/2006/main" w="25400">
+              <a:solidFill>
+                <a:srgbClr val="8993A0"/>
+              </a:solidFill>
+              <a:prstDash val="dash"/>
+            </a:ln>
+          </c:spPr>
+          <c:marker>
+            <c:symbol val="none"/>
+          </c:marker>
+          <c:cat>
+            <c:numRef>
+              <c:f>'Chart Data'!$E$2:$E$11</c:f>
+              <c:numCache>
+                <c:formatCode>General</c:formatCode>
+                <c:ptCount val="10"/>
+                <c:pt idx="0">
+                  <c:v>5.12</c:v>
+                </c:pt>
+                <c:pt idx="1">
+                  <c:v>10.24</c:v>
+                </c:pt>
+                <c:pt idx="2">
+                  <c:v>15.36</c:v>
+                </c:pt>
+                <c:pt idx="3">
+                  <c:v>20.48</c:v>
+                </c:pt>
+                <c:pt idx="4">
+                  <c:v>25.6</c:v>
+                </c:pt>
+                <c:pt idx="5">
+                  <c:v>30.72</c:v>
+                </c:pt>
+                <c:pt idx="6">
+                  <c:v>35.84</c:v>
+                </c:pt>
+                <c:pt idx="7">
+                  <c:v>40.96</c:v>
+                </c:pt>
+                <c:pt idx="8">
+                  <c:v>46.08</c:v>
+                </c:pt>
+                <c:pt idx="9">
+                  <c:v>50</c:v>
+                </c:pt>
+              </c:numCache>
+            </c:numRef>
+          </c:cat>
+          <c:val>
+            <c:numRef>
+              <c:f>'Chart Data'!$F$2:$F$11</c:f>
+              <c:numCache>
+                <c:formatCode>0.00</c:formatCode>
+                <c:ptCount val="10"/>
+                <c:pt idx="0">
+                  <c:v>0.374425</c:v>
+                </c:pt>
+                <c:pt idx="1">
+                  <c:v>0.642864</c:v>
+                </c:pt>
+                <c:pt idx="2">
+                  <c:v>0.72158</c:v>
+                </c:pt>
+                <c:pt idx="3">
+                  <c:v>0.743029</c:v>
+                </c:pt>
+                <c:pt idx="4">
+                  <c:v>0.723273</c:v>
+                </c:pt>
+                <c:pt idx="5">
+                  <c:v>0.703434</c:v>
+                </c:pt>
+                <c:pt idx="6">
+                  <c:v>0.69887</c:v>
+                </c:pt>
+                <c:pt idx="7">
+                  <c:v>0.661133</c:v>
+                </c:pt>
+                <c:pt idx="8">
+                  <c:v>0.680897</c:v>
+                </c:pt>
+                <c:pt idx="9">
+                  <c:v>0.633469</c:v>
+                </c:pt>
+              </c:numCache>
+            </c:numRef>
+          </c:val>
+          <c:smooth val="0"/>
+        </c:ser>
+        <c:dLbls>
+          <c:txPr>
+            <a:bodyPr xmlns:a="http://schemas.openxmlformats.org/drawingml/2006/main" anchorCtr="1"/>
+            <a:lstStyle xmlns:a="http://schemas.openxmlformats.org/drawingml/2006/main"/>
+            <a:p xmlns:a="http://schemas.openxmlformats.org/drawingml/2006/main">
+              <a:pPr>
+                <a:defRPr>
+                  <a:latin typeface="DejaVu Sans"/>
+                  <a:ea typeface="DejaVu Sans"/>
+                  <a:cs typeface="DejaVu Sans"/>
+                </a:defRPr>
+              </a:pPr>
+            </a:p>
+          </c:txPr>
+          <c:showLegendKey val="0"/>
+          <c:showVal val="0"/>
+          <c:showCatName val="0"/>
+          <c:showSerName val="0"/>
+          <c:showPercent val="0"/>
+          <c:showBubbleSize val="0"/>
+          <c:showLeaderLines val="0"/>
+        </c:dLbls>
+        <c:smooth val="0"/>
+        <c:axId val="48650112"/>
+        <c:axId val="48672768"/>
+      </c:lineChart>
+      <c:catAx>
+        <c:axId val="48650112"/>
+        <c:scaling>
+          <c:orientation val="minMax"/>
+        </c:scaling>
+        <c:delete val="0"/>
+        <c:axPos val="b"/>
+        <c:title>
+          <c:tx>
+            <c:rich>
+              <a:bodyPr xmlns:a="http://schemas.openxmlformats.org/drawingml/2006/main"/>
+              <a:lstStyle xmlns:a="http://schemas.openxmlformats.org/drawingml/2006/main"/>
+              <a:p xmlns:a="http://schemas.openxmlformats.org/drawingml/2006/main">
+                <a:r>
+                  <a:rPr sz="1575">
+                    <a:solidFill>
+                      <a:srgbClr val="263A4E"/>
+                    </a:solidFill>
+                    <a:latin typeface="DejaVu Sans"/>
+                    <a:ea typeface="DejaVu Sans"/>
+                    <a:cs typeface="DejaVu Sans"/>
+                  </a:rPr>
+                  <a:t>Training decisions (thousands)</a:t>
+                </a:r>
+              </a:p>
+            </c:rich>
+          </c:tx>
+          <c:overlay val="0"/>
+          <c:txPr>
+            <a:bodyPr xmlns:a="http://schemas.openxmlformats.org/drawingml/2006/main" anchorCtr="1"/>
+            <a:lstStyle xmlns:a="http://schemas.openxmlformats.org/drawingml/2006/main"/>
+            <a:p xmlns:a="http://schemas.openxmlformats.org/drawingml/2006/main">
+              <a:pPr>
+                <a:defRPr sz="1575">
+                  <a:solidFill>
+                    <a:srgbClr val="263A4E"/>
+                  </a:solidFill>
+                  <a:latin typeface="DejaVu Sans"/>
+                  <a:ea typeface="DejaVu Sans"/>
+                  <a:cs typeface="DejaVu Sans"/>
+                </a:defRPr>
+              </a:pPr>
+            </a:p>
+          </c:txPr>
+        </c:title>
+        <c:numFmt formatCode="General"/>
+        <c:majorTickMark val="none"/>
+        <c:minorTickMark val="none"/>
+        <c:tickLblPos val="low"/>
+        <c:spPr>
+          <a:ln xmlns:a="http://schemas.openxmlformats.org/drawingml/2006/main" w="9525">
+            <a:solidFill>
+              <a:srgbClr val="D4D4D4"/>
+            </a:solidFill>
+            <a:prstDash val="solid"/>
+          </a:ln>
+        </c:spPr>
+        <c:txPr>
+          <a:bodyPr xmlns:a="http://schemas.openxmlformats.org/drawingml/2006/main" anchorCtr="1"/>
+          <a:lstStyle xmlns:a="http://schemas.openxmlformats.org/drawingml/2006/main"/>
+          <a:p xmlns:a="http://schemas.openxmlformats.org/drawingml/2006/main">
+            <a:pPr>
+              <a:defRPr sz="1575">
+                <a:solidFill>
+                  <a:srgbClr val="263A4E"/>
+                </a:solidFill>
+                <a:latin typeface="DejaVu Sans"/>
+                <a:ea typeface="DejaVu Sans"/>
+                <a:cs typeface="DejaVu Sans"/>
+              </a:defRPr>
+            </a:pPr>
+          </a:p>
+        </c:txPr>
+        <c:crossAx val="48672768"/>
+      </c:catAx>
+      <c:valAx>
+        <c:axId val="48672768"/>
+        <c:scaling>
+          <c:orientation val="minMax"/>
+        </c:scaling>
+        <c:delete val="0"/>
+        <c:axPos val="l"/>
+        <c:majorGridlines>
+          <c:spPr>
+            <a:ln xmlns:a="http://schemas.openxmlformats.org/drawingml/2006/main" w="9525">
+              <a:solidFill>
+                <a:srgbClr val="DCE3E9"/>
+              </a:solidFill>
+            </a:ln>
+          </c:spPr>
+        </c:majorGridlines>
+        <c:title>
+          <c:tx>
+            <c:rich>
+              <a:bodyPr xmlns:a="http://schemas.openxmlformats.org/drawingml/2006/main"/>
+              <a:lstStyle xmlns:a="http://schemas.openxmlformats.org/drawingml/2006/main"/>
+              <a:p xmlns:a="http://schemas.openxmlformats.org/drawingml/2006/main">
+                <a:r>
+                  <a:rPr sz="1575">
+                    <a:solidFill>
+                      <a:srgbClr val="263A4E"/>
+                    </a:solidFill>
+                    <a:latin typeface="DejaVu Sans"/>
+                    <a:ea typeface="DejaVu Sans"/>
+                    <a:cs typeface="DejaVu Sans"/>
+                  </a:rPr>
+                  <a:t>Nats / probability</a:t>
+                </a:r>
+              </a:p>
+            </c:rich>
+          </c:tx>
+          <c:overlay val="0"/>
+          <c:txPr>
+            <a:bodyPr xmlns:a="http://schemas.openxmlformats.org/drawingml/2006/main" anchorCtr="1"/>
+            <a:lstStyle xmlns:a="http://schemas.openxmlformats.org/drawingml/2006/main"/>
+            <a:p xmlns:a="http://schemas.openxmlformats.org/drawingml/2006/main">
+              <a:pPr>
+                <a:defRPr sz="1575">
+                  <a:solidFill>
+                    <a:srgbClr val="263A4E"/>
+                  </a:solidFill>
+                  <a:latin typeface="DejaVu Sans"/>
+                  <a:ea typeface="DejaVu Sans"/>
+                  <a:cs typeface="DejaVu Sans"/>
+                </a:defRPr>
+              </a:pPr>
+            </a:p>
+          </c:txPr>
+        </c:title>
+        <c:numFmt formatCode="0"/>
+        <c:majorTickMark val="none"/>
+        <c:minorTickMark val="none"/>
+        <c:spPr>
+          <a:ln xmlns:a="http://schemas.openxmlformats.org/drawingml/2006/main" w="9525">
+            <a:solidFill>
+              <a:srgbClr val="D4D4D4"/>
+            </a:solidFill>
+            <a:prstDash val="solid"/>
+          </a:ln>
+        </c:spPr>
+        <c:txPr>
+          <a:bodyPr xmlns:a="http://schemas.openxmlformats.org/drawingml/2006/main" anchorCtr="1"/>
+          <a:lstStyle xmlns:a="http://schemas.openxmlformats.org/drawingml/2006/main"/>
+          <a:p xmlns:a="http://schemas.openxmlformats.org/drawingml/2006/main">
+            <a:pPr>
+              <a:defRPr sz="1575">
+                <a:solidFill>
+                  <a:srgbClr val="263A4E"/>
+                </a:solidFill>
+                <a:latin typeface="DejaVu Sans"/>
+                <a:ea typeface="DejaVu Sans"/>
+                <a:cs typeface="DejaVu Sans"/>
+              </a:defRPr>
+            </a:pPr>
+          </a:p>
+        </c:txPr>
+        <c:crossAx val="48650112"/>
+        <c:crossBetween val="between"/>
+      </c:valAx>
+      <c:spPr>
+        <a:solidFill xmlns:a="http://schemas.openxmlformats.org/drawingml/2006/main">
+          <a:srgbClr val="FFFFFF"/>
+        </a:solidFill>
+      </c:spPr>
+    </c:plotArea>
+    <c:legend>
+      <c:legendPos val="b"/>
+      <c:overlay val="0"/>
+      <c:txPr>
+        <a:bodyPr xmlns:a="http://schemas.openxmlformats.org/drawingml/2006/main" anchorCtr="1"/>
+        <a:lstStyle xmlns:a="http://schemas.openxmlformats.org/drawingml/2006/main"/>
+        <a:p xmlns:a="http://schemas.openxmlformats.org/drawingml/2006/main">
+          <a:pPr>
+            <a:defRPr sz="1575">
+              <a:solidFill>
+                <a:srgbClr val="263A4E"/>
+              </a:solidFill>
+              <a:latin typeface="DejaVu Sans"/>
+              <a:ea typeface="DejaVu Sans"/>
+              <a:cs typeface="DejaVu Sans"/>
+            </a:defRPr>
+          </a:pPr>
+        </a:p>
+      </c:txPr>
+    </c:legend>
+    <c:plotVisOnly val="1"/>
+  </c:chart>
+  <c:spPr>
+    <a:solidFill xmlns:a="http://schemas.openxmlformats.org/drawingml/2006/main">
+      <a:srgbClr val="FFFFFF"/>
+    </a:solidFill>
+    <a:ln xmlns:a="http://schemas.openxmlformats.org/drawingml/2006/main" w="0">
+      <a:noFill/>
+    </a:ln>
+  </c:spPr>
+  <c:externalData r:id="rIdChartSnapshot1">
+    <c:autoUpdate val="0"/>
+  </c:externalData>
+</c:chartSpace>
+</file>
+
 <file path=ppt/slides/slide1.xml><?xml version="1.0" encoding="utf-8"?>
 <p:sld xmlns:p="http://schemas.openxmlformats.org/presentationml/2006/main">
   <p:cSld>
@@ -6077,7 +7334,7 @@
                 <a:ea typeface="DejaVu Sans"/>
                 <a:cs typeface="DejaVu Sans"/>
               </a:rPr>
-              <a:t>Local simulator • Five training runs • Two baselines</a:t>
+              <a:t>Local simulator • Ten training seeds • Two baselines • Ablations</a:t>
             </a:r>
           </a:p>
         </p:txBody>
@@ -6304,7 +7561,7 @@
                 <a:ea typeface="DejaVu Sans"/>
                 <a:cs typeface="DejaVu Sans"/>
               </a:rPr>
-              <a:t>Mean return over the most recent 20 completed training episodes</a:t>
+              <a:t>Mean return over the latest 20 training episodes; dashed lines are the 95% CI</a:t>
             </a:r>
           </a:p>
         </p:txBody>
@@ -6993,7 +8250,7 @@
                 <a:ea typeface="DejaVu Sans"/>
                 <a:cs typeface="DejaVu Sans"/>
               </a:rPr>
-              <a:t>PPO used 23.51% more capacity than fixed. Cost goal failed.</a:t>
+              <a:t>PPO used 23.85% more capacity than fixed. Cost goal failed.</a:t>
             </a:r>
           </a:p>
         </p:txBody>
@@ -7059,7 +8316,7 @@
                 <a:ea typeface="DejaVu Sans"/>
                 <a:cs typeface="DejaVu Sans"/>
               </a:rPr>
-              <a:t>About 172 invalid actions / 180 decisions: additions at the limit.</a:t>
+              <a:t>About 167 invalid actions / 180 decisions: additions at the limit.</a:t>
             </a:r>
           </a:p>
         </p:txBody>
@@ -7440,7 +8697,7 @@
                 <a:ea typeface="DejaVu Sans"/>
                 <a:cs typeface="DejaVu Sans"/>
               </a:rPr>
-              <a:t>PPO steady mean: 5.05% → narrowly misses the limit.</a:t>
+              <a:t>PPO steady: 4.18%, 95% CI [2.05, 6.31] crosses the limit.</a:t>
             </a:r>
           </a:p>
         </p:txBody>
@@ -7506,7 +8763,7 @@
                 <a:ea typeface="DejaVu Sans"/>
                 <a:cs typeface="DejaVu Sans"/>
               </a:rPr>
-              <a:t>Across seeds: 1.81–5.11% overall violations. No significance claim.</a:t>
+              <a:t>10 seeds: 1.81–5.11% overall; mean 2.21% [1.47, 2.94].</a:t>
             </a:r>
           </a:p>
         </p:txBody>
@@ -7799,7 +9056,7 @@
                 <a:ea typeface="DejaVu Sans"/>
                 <a:cs typeface="DejaVu Sans"/>
               </a:rPr>
-              <a:t>13</a:t>
+              <a:t>15</a:t>
             </a:r>
           </a:p>
         </p:txBody>
@@ -7977,7 +9234,7 @@
                 <a:ea typeface="DejaVu Sans"/>
                 <a:cs typeface="DejaVu Sans"/>
               </a:rPr>
-              <a:t>Policy seed 2: selected by validation.</a:t>
+              <a:t>Policy seed 1: selected by validation.</a:t>
             </a:r>
           </a:p>
         </p:txBody>
@@ -8336,7 +9593,7 @@
                 <a:ea typeface="DejaVu Sans"/>
                 <a:cs typeface="DejaVu Sans"/>
               </a:rPr>
-              <a:t>14</a:t>
+              <a:t>16</a:t>
             </a:r>
           </a:p>
         </p:txBody>
@@ -9025,7 +10282,7 @@
                 <a:ea typeface="DejaVu Sans"/>
                 <a:cs typeface="DejaVu Sans"/>
               </a:rPr>
-              <a:t>15</a:t>
+              <a:t>17</a:t>
             </a:r>
           </a:p>
         </p:txBody>
@@ -9157,7 +10414,7 @@
                 <a:ea typeface="DejaVu Sans"/>
                 <a:cs typeface="DejaVu Sans"/>
               </a:rPr>
-              <a:t>Lower average violations, but 23.51% more capacity than fixed.</a:t>
+              <a:t>Lower average violations, but 23.85% more capacity than fixed.</a:t>
             </a:r>
           </a:p>
         </p:txBody>
@@ -9289,7 +10546,7 @@
                 <a:ea typeface="DejaVu Sans"/>
                 <a:cs typeface="DejaVu Sans"/>
               </a:rPr>
-              <a:t>Mask invalid actions; study reward balance; strengthen baselines.</a:t>
+              <a:t>63% of policy mass is rejected: mask invalid actions; revisit reward.</a:t>
             </a:r>
           </a:p>
         </p:txBody>
@@ -9421,7 +10678,7 @@
                 <a:ea typeface="DejaVu Sans"/>
                 <a:cs typeface="DejaVu Sans"/>
               </a:rPr>
-              <a:t>More workloads and seeds, fresh held-out tests, eventually real traces.</a:t>
+              <a:t>Stronger baselines, more workloads, fresh held-out tests, real traces.</a:t>
             </a:r>
           </a:p>
         </p:txBody>
@@ -9714,7 +10971,7 @@
                 <a:ea typeface="DejaVu Sans"/>
                 <a:cs typeface="DejaVu Sans"/>
               </a:rPr>
-              <a:t>16</a:t>
+              <a:t>18</a:t>
             </a:r>
           </a:p>
         </p:txBody>
@@ -10836,7 +12093,7 @@
                 <a:ea typeface="DejaVu Sans"/>
                 <a:cs typeface="DejaVu Sans"/>
               </a:rPr>
-              <a:t>AI disclosure: OpenAI ChatGPT assisted code, tests, analysis, slides, and narration.</a:t>
+              <a:t>AI disclosure: ChatGPT and Claude assisted code, analysis, slides, and narration.</a:t>
             </a:r>
           </a:p>
           <a:p xmlns:a="http://schemas.openxmlformats.org/drawingml/2006/main">
@@ -10868,6 +12125,922 @@
     <p:extLst>
       <p:ext uri="{BB962C8B-B14F-4D97-AF65-F5344CB8AC3E}">
         <p14:creationId xmlns:p14="http://schemas.microsoft.com/office/powerpoint/2010/main" val="1087429791"/>
+      </p:ext>
+    </p:extLst>
+  </p:cSld>
+</p:sld>
+</file>
+
+<file path=ppt/slides/slide17.xml><?xml version="1.0" encoding="utf-8"?>
+<p:sld xmlns:p="http://schemas.openxmlformats.org/presentationml/2006/main">
+  <p:cSld>
+    <p:bg>
+      <p:bgPr>
+        <a:solidFill xmlns:a="http://schemas.openxmlformats.org/drawingml/2006/main">
+          <a:srgbClr val="FFFFFF"/>
+        </a:solidFill>
+      </p:bgPr>
+    </p:bg>
+    <p:spTree>
+      <p:nvGrpSpPr>
+        <p:cNvPr id="1" name=""/>
+        <p:cNvGrpSpPr/>
+        <p:nvPr/>
+      </p:nvGrpSpPr>
+      <p:grpSpPr>
+        <a:xfrm xmlns:a="http://schemas.openxmlformats.org/drawingml/2006/main"/>
+      </p:grpSpPr>
+      <p:sp>
+        <p:nvSpPr>
+          <p:cNvPr id="9" name="">
+            <a:extLst xmlns:a="http://schemas.openxmlformats.org/drawingml/2006/main">
+              <a:ext uri="{FF2B5EF4-FFF2-40B4-BE49-F238E27FC236}">
+                <a16:creationId xmlns:a16="http://schemas.microsoft.com/office/drawing/2014/main" id="{6E5A8816-104D-4FAC-BBD0-0A7B930578D0}"/>
+              </a:ext>
+            </a:extLst>
+          </p:cNvPr>
+          <p:cNvSpPr>
+            <a:spLocks xmlns:a="http://schemas.openxmlformats.org/drawingml/2006/main" noGrp="1"/>
+          </p:cNvSpPr>
+          <p:nvPr/>
+        </p:nvSpPr>
+        <p:spPr>
+          <a:xfrm xmlns:a="http://schemas.openxmlformats.org/drawingml/2006/main">
+            <a:off x="609600" y="457200"/>
+            <a:ext cx="10972800" cy="704850"/>
+          </a:xfrm>
+          <a:prstGeom xmlns:a="http://schemas.openxmlformats.org/drawingml/2006/main" prst="rect">
+            <a:avLst/>
+          </a:prstGeom>
+          <a:noFill xmlns:a="http://schemas.openxmlformats.org/drawingml/2006/main"/>
+          <a:ln xmlns:a="http://schemas.openxmlformats.org/drawingml/2006/main" w="0">
+            <a:noFill/>
+          </a:ln>
+        </p:spPr>
+        <p:txBody>
+          <a:bodyPr xmlns:a="http://schemas.openxmlformats.org/drawingml/2006/main"/>
+          <a:lstStyle xmlns:a="http://schemas.openxmlformats.org/drawingml/2006/main">
+            <a:defPPr>
+              <a:defRPr sz="3150" b="1">
+                <a:solidFill>
+                  <a:srgbClr val="172D44"/>
+                </a:solidFill>
+                <a:latin typeface="DejaVu Sans"/>
+                <a:ea typeface="DejaVu Sans"/>
+                <a:cs typeface="DejaVu Sans"/>
+              </a:defRPr>
+            </a:defPPr>
+          </a:lstStyle>
+          <a:p xmlns:a="http://schemas.openxmlformats.org/drawingml/2006/main">
+            <a:pPr>
+              <a:defRPr sz="3150" b="1">
+                <a:solidFill>
+                  <a:srgbClr val="172D44"/>
+                </a:solidFill>
+                <a:latin typeface="DejaVu Sans"/>
+                <a:ea typeface="DejaVu Sans"/>
+                <a:cs typeface="DejaVu Sans"/>
+              </a:defRPr>
+            </a:pPr>
+            <a:r>
+              <a:rPr sz="3150" b="1">
+                <a:solidFill>
+                  <a:srgbClr val="172D44"/>
+                </a:solidFill>
+                <a:latin typeface="DejaVu Sans"/>
+                <a:ea typeface="DejaVu Sans"/>
+                <a:cs typeface="DejaVu Sans"/>
+              </a:rPr>
+              <a:t>Ablations: what clipping and GAE contribute</a:t>
+            </a:r>
+          </a:p>
+        </p:txBody>
+      </p:sp>
+      <p:sp>
+        <p:nvSpPr>
+          <p:cNvPr id="2" name="">
+            <a:extLst xmlns:a="http://schemas.openxmlformats.org/drawingml/2006/main">
+              <a:ext uri="{FF2B5EF4-FFF2-40B4-BE49-F238E27FC236}">
+                <a16:creationId xmlns:a16="http://schemas.microsoft.com/office/drawing/2014/main" id="{202AB2EF-FBB5-4EF2-B525-2A4E9227EF8A}"/>
+              </a:ext>
+            </a:extLst>
+          </p:cNvPr>
+          <p:cNvSpPr>
+            <a:spLocks xmlns:a="http://schemas.openxmlformats.org/drawingml/2006/main" noGrp="1"/>
+          </p:cNvSpPr>
+          <p:nvPr/>
+        </p:nvSpPr>
+        <p:spPr>
+          <a:xfrm xmlns:a="http://schemas.openxmlformats.org/drawingml/2006/main">
+            <a:off x="628650" y="1219200"/>
+            <a:ext cx="10858500" cy="552450"/>
+          </a:xfrm>
+          <a:prstGeom xmlns:a="http://schemas.openxmlformats.org/drawingml/2006/main" prst="rect">
+            <a:avLst/>
+          </a:prstGeom>
+          <a:noFill xmlns:a="http://schemas.openxmlformats.org/drawingml/2006/main"/>
+          <a:ln xmlns:a="http://schemas.openxmlformats.org/drawingml/2006/main" w="0">
+            <a:noFill/>
+          </a:ln>
+        </p:spPr>
+        <p:txBody>
+          <a:bodyPr xmlns:a="http://schemas.openxmlformats.org/drawingml/2006/main"/>
+          <a:lstStyle xmlns:a="http://schemas.openxmlformats.org/drawingml/2006/main">
+            <a:defPPr>
+              <a:defRPr sz="1875" b="0">
+                <a:solidFill>
+                  <a:srgbClr val="5B6B7C"/>
+                </a:solidFill>
+                <a:latin typeface="DejaVu Sans"/>
+                <a:ea typeface="DejaVu Sans"/>
+                <a:cs typeface="DejaVu Sans"/>
+              </a:defRPr>
+            </a:defPPr>
+          </a:lstStyle>
+          <a:p xmlns:a="http://schemas.openxmlformats.org/drawingml/2006/main">
+            <a:pPr>
+              <a:defRPr sz="1875" b="0">
+                <a:solidFill>
+                  <a:srgbClr val="5B6B7C"/>
+                </a:solidFill>
+                <a:latin typeface="DejaVu Sans"/>
+                <a:ea typeface="DejaVu Sans"/>
+                <a:cs typeface="DejaVu Sans"/>
+              </a:defRPr>
+            </a:pPr>
+            <a:r>
+              <a:rPr sz="1875" b="0">
+                <a:solidFill>
+                  <a:srgbClr val="5B6B7C"/>
+                </a:solidFill>
+                <a:latin typeface="DejaVu Sans"/>
+                <a:ea typeface="DejaVu Sans"/>
+                <a:cs typeface="DejaVu Sans"/>
+              </a:rPr>
+              <a:t>10 paired seeds per variant: same initial weights and training traffic</a:t>
+            </a:r>
+          </a:p>
+        </p:txBody>
+      </p:sp>
+      <p:sp>
+        <p:nvSpPr>
+          <p:cNvPr id="3" name="">
+            <a:extLst xmlns:a="http://schemas.openxmlformats.org/drawingml/2006/main">
+              <a:ext uri="{FF2B5EF4-FFF2-40B4-BE49-F238E27FC236}">
+                <a16:creationId xmlns:a16="http://schemas.microsoft.com/office/drawing/2014/main" id="{A8E7FDCB-73D1-4FD7-8DC8-EC47EFF72449}"/>
+              </a:ext>
+            </a:extLst>
+          </p:cNvPr>
+          <p:cNvSpPr>
+            <a:spLocks xmlns:a="http://schemas.openxmlformats.org/drawingml/2006/main" noGrp="1"/>
+          </p:cNvSpPr>
+          <p:nvPr/>
+        </p:nvSpPr>
+        <p:spPr>
+          <a:xfrm xmlns:a="http://schemas.openxmlformats.org/drawingml/2006/main">
+            <a:off x="628650" y="6438900"/>
+            <a:ext cx="10096500" cy="266700"/>
+          </a:xfrm>
+          <a:prstGeom xmlns:a="http://schemas.openxmlformats.org/drawingml/2006/main" prst="rect">
+            <a:avLst/>
+          </a:prstGeom>
+          <a:noFill xmlns:a="http://schemas.openxmlformats.org/drawingml/2006/main"/>
+          <a:ln xmlns:a="http://schemas.openxmlformats.org/drawingml/2006/main" w="0">
+            <a:noFill/>
+          </a:ln>
+        </p:spPr>
+        <p:txBody>
+          <a:bodyPr xmlns:a="http://schemas.openxmlformats.org/drawingml/2006/main"/>
+          <a:lstStyle xmlns:a="http://schemas.openxmlformats.org/drawingml/2006/main">
+            <a:defPPr>
+              <a:defRPr sz="1200" b="0">
+                <a:solidFill>
+                  <a:srgbClr val="5B6B7C"/>
+                </a:solidFill>
+                <a:latin typeface="DejaVu Sans"/>
+                <a:ea typeface="DejaVu Sans"/>
+                <a:cs typeface="DejaVu Sans"/>
+              </a:defRPr>
+            </a:defPPr>
+          </a:lstStyle>
+          <a:p xmlns:a="http://schemas.openxmlformats.org/drawingml/2006/main">
+            <a:pPr>
+              <a:defRPr sz="1200" b="0">
+                <a:solidFill>
+                  <a:srgbClr val="5B6B7C"/>
+                </a:solidFill>
+                <a:latin typeface="DejaVu Sans"/>
+                <a:ea typeface="DejaVu Sans"/>
+                <a:cs typeface="DejaVu Sans"/>
+              </a:defRPr>
+            </a:pPr>
+            <a:r>
+              <a:rPr sz="1200" b="0">
+                <a:solidFill>
+                  <a:srgbClr val="5B6B7C"/>
+                </a:solidFill>
+                <a:latin typeface="DejaVu Sans"/>
+                <a:ea typeface="DejaVu Sans"/>
+                <a:cs typeface="DejaVu Sans"/>
+              </a:rPr>
+              <a:t>SIMULATED API AUTOSCALING • PART 2</a:t>
+            </a:r>
+          </a:p>
+        </p:txBody>
+      </p:sp>
+      <p:sp>
+        <p:nvSpPr>
+          <p:cNvPr id="4" name="">
+            <a:extLst xmlns:a="http://schemas.openxmlformats.org/drawingml/2006/main">
+              <a:ext uri="{FF2B5EF4-FFF2-40B4-BE49-F238E27FC236}">
+                <a16:creationId xmlns:a16="http://schemas.microsoft.com/office/drawing/2014/main" id="{70A8902A-1451-4FCE-BD81-CF2B4CD33551}"/>
+              </a:ext>
+            </a:extLst>
+          </p:cNvPr>
+          <p:cNvSpPr>
+            <a:spLocks xmlns:a="http://schemas.openxmlformats.org/drawingml/2006/main" noGrp="1"/>
+          </p:cNvSpPr>
+          <p:nvPr/>
+        </p:nvSpPr>
+        <p:spPr>
+          <a:xfrm xmlns:a="http://schemas.openxmlformats.org/drawingml/2006/main">
+            <a:off x="11182350" y="6381750"/>
+            <a:ext cx="476250" cy="342900"/>
+          </a:xfrm>
+          <a:prstGeom xmlns:a="http://schemas.openxmlformats.org/drawingml/2006/main" prst="rect">
+            <a:avLst/>
+          </a:prstGeom>
+          <a:noFill xmlns:a="http://schemas.openxmlformats.org/drawingml/2006/main"/>
+          <a:ln xmlns:a="http://schemas.openxmlformats.org/drawingml/2006/main" w="0">
+            <a:noFill/>
+          </a:ln>
+        </p:spPr>
+        <p:txBody>
+          <a:bodyPr xmlns:a="http://schemas.openxmlformats.org/drawingml/2006/main"/>
+          <a:lstStyle xmlns:a="http://schemas.openxmlformats.org/drawingml/2006/main">
+            <a:defPPr>
+              <a:defRPr sz="1425" b="0">
+                <a:solidFill>
+                  <a:srgbClr val="5B6B7C"/>
+                </a:solidFill>
+                <a:latin typeface="DejaVu Sans"/>
+                <a:ea typeface="DejaVu Sans"/>
+                <a:cs typeface="DejaVu Sans"/>
+              </a:defRPr>
+            </a:defPPr>
+          </a:lstStyle>
+          <a:p xmlns:a="http://schemas.openxmlformats.org/drawingml/2006/main">
+            <a:pPr>
+              <a:defRPr sz="1425" b="0">
+                <a:solidFill>
+                  <a:srgbClr val="5B6B7C"/>
+                </a:solidFill>
+                <a:latin typeface="DejaVu Sans"/>
+                <a:ea typeface="DejaVu Sans"/>
+                <a:cs typeface="DejaVu Sans"/>
+              </a:defRPr>
+            </a:pPr>
+            <a:r>
+              <a:rPr sz="1425" b="0">
+                <a:solidFill>
+                  <a:srgbClr val="5B6B7C"/>
+                </a:solidFill>
+                <a:latin typeface="DejaVu Sans"/>
+                <a:ea typeface="DejaVu Sans"/>
+                <a:cs typeface="DejaVu Sans"/>
+              </a:rPr>
+              <a:t>13</a:t>
+            </a:r>
+          </a:p>
+        </p:txBody>
+      </p:sp>
+      <p:graphicFrame>
+        <p:nvGraphicFramePr>
+          <p:cNvPr id="5" name="Chart">
+            <a:extLst xmlns:a="http://schemas.openxmlformats.org/drawingml/2006/main">
+              <a:ext uri="{FF2B5EF4-FFF2-40B4-BE49-F238E27FC236}">
+                <a16:creationId xmlns:a16="http://schemas.microsoft.com/office/drawing/2014/main" id="{BB58B0CF-4B2C-4933-99A1-F0BD503EDF00}"/>
+              </a:ext>
+            </a:extLst>
+          </p:cNvPr>
+          <p:cNvGraphicFramePr/>
+          <p:nvPr/>
+        </p:nvGraphicFramePr>
+        <p:xfrm>
+          <a:off xmlns:a="http://schemas.openxmlformats.org/drawingml/2006/main" x="628650" y="1924050"/>
+          <a:ext xmlns:a="http://schemas.openxmlformats.org/drawingml/2006/main" cx="5248275" cy="3171825"/>
+        </p:xfrm>
+        <a:graphic xmlns:a="http://schemas.openxmlformats.org/drawingml/2006/main">
+          <a:graphicData uri="http://schemas.openxmlformats.org/drawingml/2006/chart">
+            <c:chart xmlns:r="http://schemas.openxmlformats.org/officeDocument/2006/relationships" xmlns:c="http://schemas.openxmlformats.org/drawingml/2006/chart" r:id="Re33e3304bb864a1b"/>
+          </a:graphicData>
+        </a:graphic>
+      </p:graphicFrame>
+      <p:graphicFrame>
+        <p:nvGraphicFramePr>
+          <p:cNvPr id="6" name="Chart">
+            <a:extLst xmlns:a="http://schemas.openxmlformats.org/drawingml/2006/main">
+              <a:ext uri="{FF2B5EF4-FFF2-40B4-BE49-F238E27FC236}">
+                <a16:creationId xmlns:a16="http://schemas.microsoft.com/office/drawing/2014/main" id="{363F0AF6-F900-49BB-82E1-77B2D0DA40F5}"/>
+              </a:ext>
+            </a:extLst>
+          </p:cNvPr>
+          <p:cNvGraphicFramePr/>
+          <p:nvPr/>
+        </p:nvGraphicFramePr>
+        <p:xfrm>
+          <a:off xmlns:a="http://schemas.openxmlformats.org/drawingml/2006/main" x="6134100" y="1924050"/>
+          <a:ext xmlns:a="http://schemas.openxmlformats.org/drawingml/2006/main" cx="5248275" cy="3171825"/>
+        </p:xfrm>
+        <a:graphic xmlns:a="http://schemas.openxmlformats.org/drawingml/2006/main">
+          <a:graphicData uri="http://schemas.openxmlformats.org/drawingml/2006/chart">
+            <c:chart xmlns:r="http://schemas.openxmlformats.org/officeDocument/2006/relationships" xmlns:c="http://schemas.openxmlformats.org/drawingml/2006/chart" r:id="R3326cb004b684c1f"/>
+          </a:graphicData>
+        </a:graphic>
+      </p:graphicFrame>
+      <p:sp>
+        <p:nvSpPr>
+          <p:cNvPr id="7" name="">
+            <a:extLst xmlns:a="http://schemas.openxmlformats.org/drawingml/2006/main">
+              <a:ext uri="{FF2B5EF4-FFF2-40B4-BE49-F238E27FC236}">
+                <a16:creationId xmlns:a16="http://schemas.microsoft.com/office/drawing/2014/main" id="{08D7C428-71A1-4AF7-A6E5-3D94650F12FA}"/>
+              </a:ext>
+            </a:extLst>
+          </p:cNvPr>
+          <p:cNvSpPr>
+            <a:spLocks xmlns:a="http://schemas.openxmlformats.org/drawingml/2006/main" noGrp="1"/>
+          </p:cNvSpPr>
+          <p:nvPr/>
+        </p:nvSpPr>
+        <p:spPr>
+          <a:xfrm xmlns:a="http://schemas.openxmlformats.org/drawingml/2006/main">
+            <a:off x="628650" y="5248275"/>
+            <a:ext cx="10858500" cy="495300"/>
+          </a:xfrm>
+          <a:prstGeom xmlns:a="http://schemas.openxmlformats.org/drawingml/2006/main" prst="rect">
+            <a:avLst/>
+          </a:prstGeom>
+          <a:noFill xmlns:a="http://schemas.openxmlformats.org/drawingml/2006/main"/>
+          <a:ln xmlns:a="http://schemas.openxmlformats.org/drawingml/2006/main" w="0">
+            <a:noFill/>
+          </a:ln>
+        </p:spPr>
+        <p:txBody>
+          <a:bodyPr xmlns:a="http://schemas.openxmlformats.org/drawingml/2006/main"/>
+          <a:lstStyle xmlns:a="http://schemas.openxmlformats.org/drawingml/2006/main">
+            <a:defPPr>
+              <a:defRPr sz="2175" b="1">
+                <a:solidFill>
+                  <a:srgbClr val="DC7841"/>
+                </a:solidFill>
+                <a:latin typeface="DejaVu Sans"/>
+                <a:ea typeface="DejaVu Sans"/>
+                <a:cs typeface="DejaVu Sans"/>
+              </a:defRPr>
+            </a:defPPr>
+          </a:lstStyle>
+          <a:p xmlns:a="http://schemas.openxmlformats.org/drawingml/2006/main">
+            <a:pPr>
+              <a:defRPr sz="2175" b="1">
+                <a:solidFill>
+                  <a:srgbClr val="DC7841"/>
+                </a:solidFill>
+                <a:latin typeface="DejaVu Sans"/>
+                <a:ea typeface="DejaVu Sans"/>
+                <a:cs typeface="DejaVu Sans"/>
+              </a:defRPr>
+            </a:pPr>
+            <a:r>
+              <a:rPr sz="2175" b="1">
+                <a:solidFill>
+                  <a:srgbClr val="DC7841"/>
+                </a:solidFill>
+                <a:latin typeface="DejaVu Sans"/>
+                <a:ea typeface="DejaVu Sans"/>
+                <a:cs typeface="DejaVu Sans"/>
+              </a:rPr>
+              <a:t>No clip: ~1k decisions faster, 13× KL, one run collapsed.</a:t>
+            </a:r>
+          </a:p>
+        </p:txBody>
+      </p:sp>
+      <p:sp>
+        <p:nvSpPr>
+          <p:cNvPr id="8" name="">
+            <a:extLst xmlns:a="http://schemas.openxmlformats.org/drawingml/2006/main">
+              <a:ext uri="{FF2B5EF4-FFF2-40B4-BE49-F238E27FC236}">
+                <a16:creationId xmlns:a16="http://schemas.microsoft.com/office/drawing/2014/main" id="{7B4018CF-36A9-4B75-B6CF-0ECAAA1A810C}"/>
+              </a:ext>
+            </a:extLst>
+          </p:cNvPr>
+          <p:cNvSpPr>
+            <a:spLocks xmlns:a="http://schemas.openxmlformats.org/drawingml/2006/main" noGrp="1"/>
+          </p:cNvSpPr>
+          <p:nvPr/>
+        </p:nvSpPr>
+        <p:spPr>
+          <a:xfrm xmlns:a="http://schemas.openxmlformats.org/drawingml/2006/main">
+            <a:off x="628650" y="5838825"/>
+            <a:ext cx="10858500" cy="409575"/>
+          </a:xfrm>
+          <a:prstGeom xmlns:a="http://schemas.openxmlformats.org/drawingml/2006/main" prst="rect">
+            <a:avLst/>
+          </a:prstGeom>
+          <a:noFill xmlns:a="http://schemas.openxmlformats.org/drawingml/2006/main"/>
+          <a:ln xmlns:a="http://schemas.openxmlformats.org/drawingml/2006/main" w="0">
+            <a:noFill/>
+          </a:ln>
+        </p:spPr>
+        <p:txBody>
+          <a:bodyPr xmlns:a="http://schemas.openxmlformats.org/drawingml/2006/main"/>
+          <a:lstStyle xmlns:a="http://schemas.openxmlformats.org/drawingml/2006/main">
+            <a:defPPr>
+              <a:defRPr sz="1800" b="0">
+                <a:solidFill>
+                  <a:srgbClr val="5B6B7C"/>
+                </a:solidFill>
+                <a:latin typeface="DejaVu Sans"/>
+                <a:ea typeface="DejaVu Sans"/>
+                <a:cs typeface="DejaVu Sans"/>
+              </a:defRPr>
+            </a:defPPr>
+          </a:lstStyle>
+          <a:p xmlns:a="http://schemas.openxmlformats.org/drawingml/2006/main">
+            <a:pPr>
+              <a:defRPr sz="1800" b="0">
+                <a:solidFill>
+                  <a:srgbClr val="5B6B7C"/>
+                </a:solidFill>
+                <a:latin typeface="DejaVu Sans"/>
+                <a:ea typeface="DejaVu Sans"/>
+                <a:cs typeface="DejaVu Sans"/>
+              </a:defRPr>
+            </a:pPr>
+            <a:r>
+              <a:rPr sz="1800" b="0">
+                <a:solidFill>
+                  <a:srgbClr val="5B6B7C"/>
+                </a:solidFill>
+                <a:latin typeface="DejaVu Sans"/>
+                <a:ea typeface="DejaVu Sans"/>
+                <a:cs typeface="DejaVu Sans"/>
+              </a:rPr>
+              <a:t>λ = 1 matches full PPO; λ = 0 is slowest and least stable.</a:t>
+            </a:r>
+          </a:p>
+        </p:txBody>
+      </p:sp>
+    </p:spTree>
+    <p:extLst>
+      <p:ext uri="{BB962C8B-B14F-4D97-AF65-F5344CB8AC3E}">
+        <p14:creationId xmlns:p14="http://schemas.microsoft.com/office/powerpoint/2010/main" val="1368014033"/>
+      </p:ext>
+    </p:extLst>
+  </p:cSld>
+</p:sld>
+</file>
+
+<file path=ppt/slides/slide18.xml><?xml version="1.0" encoding="utf-8"?>
+<p:sld xmlns:p="http://schemas.openxmlformats.org/presentationml/2006/main">
+  <p:cSld>
+    <p:bg>
+      <p:bgPr>
+        <a:solidFill xmlns:a="http://schemas.openxmlformats.org/drawingml/2006/main">
+          <a:srgbClr val="FFFFFF"/>
+        </a:solidFill>
+      </p:bgPr>
+    </p:bg>
+    <p:spTree>
+      <p:nvGrpSpPr>
+        <p:cNvPr id="1" name=""/>
+        <p:cNvGrpSpPr/>
+        <p:nvPr/>
+      </p:nvGrpSpPr>
+      <p:grpSpPr>
+        <a:xfrm xmlns:a="http://schemas.openxmlformats.org/drawingml/2006/main"/>
+      </p:grpSpPr>
+      <p:sp>
+        <p:nvSpPr>
+          <p:cNvPr id="8" name="">
+            <a:extLst xmlns:a="http://schemas.openxmlformats.org/drawingml/2006/main">
+              <a:ext uri="{FF2B5EF4-FFF2-40B4-BE49-F238E27FC236}">
+                <a16:creationId xmlns:a16="http://schemas.microsoft.com/office/drawing/2014/main" id="{5F5E9558-1348-49DB-B6B3-8FD462C32CD3}"/>
+              </a:ext>
+            </a:extLst>
+          </p:cNvPr>
+          <p:cNvSpPr>
+            <a:spLocks xmlns:a="http://schemas.openxmlformats.org/drawingml/2006/main" noGrp="1"/>
+          </p:cNvSpPr>
+          <p:nvPr/>
+        </p:nvSpPr>
+        <p:spPr>
+          <a:xfrm xmlns:a="http://schemas.openxmlformats.org/drawingml/2006/main">
+            <a:off x="609600" y="457200"/>
+            <a:ext cx="10972800" cy="704850"/>
+          </a:xfrm>
+          <a:prstGeom xmlns:a="http://schemas.openxmlformats.org/drawingml/2006/main" prst="rect">
+            <a:avLst/>
+          </a:prstGeom>
+          <a:noFill xmlns:a="http://schemas.openxmlformats.org/drawingml/2006/main"/>
+          <a:ln xmlns:a="http://schemas.openxmlformats.org/drawingml/2006/main" w="0">
+            <a:noFill/>
+          </a:ln>
+        </p:spPr>
+        <p:txBody>
+          <a:bodyPr xmlns:a="http://schemas.openxmlformats.org/drawingml/2006/main"/>
+          <a:lstStyle xmlns:a="http://schemas.openxmlformats.org/drawingml/2006/main">
+            <a:defPPr>
+              <a:defRPr sz="3150" b="1">
+                <a:solidFill>
+                  <a:srgbClr val="172D44"/>
+                </a:solidFill>
+                <a:latin typeface="DejaVu Sans"/>
+                <a:ea typeface="DejaVu Sans"/>
+                <a:cs typeface="DejaVu Sans"/>
+              </a:defRPr>
+            </a:defPPr>
+          </a:lstStyle>
+          <a:p xmlns:a="http://schemas.openxmlformats.org/drawingml/2006/main">
+            <a:pPr>
+              <a:defRPr sz="3150" b="1">
+                <a:solidFill>
+                  <a:srgbClr val="172D44"/>
+                </a:solidFill>
+                <a:latin typeface="DejaVu Sans"/>
+                <a:ea typeface="DejaVu Sans"/>
+                <a:cs typeface="DejaVu Sans"/>
+              </a:defRPr>
+            </a:pPr>
+            <a:r>
+              <a:rPr sz="3150" b="1">
+                <a:solidFill>
+                  <a:srgbClr val="172D44"/>
+                </a:solidFill>
+                <a:latin typeface="DejaVu Sans"/>
+                <a:ea typeface="DejaVu Sans"/>
+                <a:cs typeface="DejaVu Sans"/>
+              </a:rPr>
+              <a:t>The policy's entropy hides inactive choices</a:t>
+            </a:r>
+          </a:p>
+        </p:txBody>
+      </p:sp>
+      <p:sp>
+        <p:nvSpPr>
+          <p:cNvPr id="2" name="">
+            <a:extLst xmlns:a="http://schemas.openxmlformats.org/drawingml/2006/main">
+              <a:ext uri="{FF2B5EF4-FFF2-40B4-BE49-F238E27FC236}">
+                <a16:creationId xmlns:a16="http://schemas.microsoft.com/office/drawing/2014/main" id="{FFFC883C-BD85-4A39-AA2C-08814FF1098E}"/>
+              </a:ext>
+            </a:extLst>
+          </p:cNvPr>
+          <p:cNvSpPr>
+            <a:spLocks xmlns:a="http://schemas.openxmlformats.org/drawingml/2006/main" noGrp="1"/>
+          </p:cNvSpPr>
+          <p:nvPr/>
+        </p:nvSpPr>
+        <p:spPr>
+          <a:xfrm xmlns:a="http://schemas.openxmlformats.org/drawingml/2006/main">
+            <a:off x="628650" y="1219200"/>
+            <a:ext cx="10858500" cy="552450"/>
+          </a:xfrm>
+          <a:prstGeom xmlns:a="http://schemas.openxmlformats.org/drawingml/2006/main" prst="rect">
+            <a:avLst/>
+          </a:prstGeom>
+          <a:noFill xmlns:a="http://schemas.openxmlformats.org/drawingml/2006/main"/>
+          <a:ln xmlns:a="http://schemas.openxmlformats.org/drawingml/2006/main" w="0">
+            <a:noFill/>
+          </a:ln>
+        </p:spPr>
+        <p:txBody>
+          <a:bodyPr xmlns:a="http://schemas.openxmlformats.org/drawingml/2006/main"/>
+          <a:lstStyle xmlns:a="http://schemas.openxmlformats.org/drawingml/2006/main">
+            <a:defPPr>
+              <a:defRPr sz="1875" b="0">
+                <a:solidFill>
+                  <a:srgbClr val="5B6B7C"/>
+                </a:solidFill>
+                <a:latin typeface="DejaVu Sans"/>
+                <a:ea typeface="DejaVu Sans"/>
+                <a:cs typeface="DejaVu Sans"/>
+              </a:defRPr>
+            </a:defPPr>
+          </a:lstStyle>
+          <a:p xmlns:a="http://schemas.openxmlformats.org/drawingml/2006/main">
+            <a:pPr>
+              <a:defRPr sz="1875" b="0">
+                <a:solidFill>
+                  <a:srgbClr val="5B6B7C"/>
+                </a:solidFill>
+                <a:latin typeface="DejaVu Sans"/>
+                <a:ea typeface="DejaVu Sans"/>
+                <a:cs typeface="DejaVu Sans"/>
+              </a:defRPr>
+            </a:pPr>
+            <a:r>
+              <a:rPr sz="1875" b="0">
+                <a:solidFill>
+                  <a:srgbClr val="5B6B7C"/>
+                </a:solidFill>
+                <a:latin typeface="DejaVu Sans"/>
+                <a:ea typeface="DejaVu Sans"/>
+                <a:cs typeface="DejaVu Sans"/>
+              </a:rPr>
+              <a:t>Rollout states; invalid remove/add are executed as hold</a:t>
+            </a:r>
+          </a:p>
+        </p:txBody>
+      </p:sp>
+      <p:sp>
+        <p:nvSpPr>
+          <p:cNvPr id="3" name="">
+            <a:extLst xmlns:a="http://schemas.openxmlformats.org/drawingml/2006/main">
+              <a:ext uri="{FF2B5EF4-FFF2-40B4-BE49-F238E27FC236}">
+                <a16:creationId xmlns:a16="http://schemas.microsoft.com/office/drawing/2014/main" id="{C2B4A5F6-BC67-4B89-8019-55C961292FAB}"/>
+              </a:ext>
+            </a:extLst>
+          </p:cNvPr>
+          <p:cNvSpPr>
+            <a:spLocks xmlns:a="http://schemas.openxmlformats.org/drawingml/2006/main" noGrp="1"/>
+          </p:cNvSpPr>
+          <p:nvPr/>
+        </p:nvSpPr>
+        <p:spPr>
+          <a:xfrm xmlns:a="http://schemas.openxmlformats.org/drawingml/2006/main">
+            <a:off x="628650" y="6438900"/>
+            <a:ext cx="10096500" cy="266700"/>
+          </a:xfrm>
+          <a:prstGeom xmlns:a="http://schemas.openxmlformats.org/drawingml/2006/main" prst="rect">
+            <a:avLst/>
+          </a:prstGeom>
+          <a:noFill xmlns:a="http://schemas.openxmlformats.org/drawingml/2006/main"/>
+          <a:ln xmlns:a="http://schemas.openxmlformats.org/drawingml/2006/main" w="0">
+            <a:noFill/>
+          </a:ln>
+        </p:spPr>
+        <p:txBody>
+          <a:bodyPr xmlns:a="http://schemas.openxmlformats.org/drawingml/2006/main"/>
+          <a:lstStyle xmlns:a="http://schemas.openxmlformats.org/drawingml/2006/main">
+            <a:defPPr>
+              <a:defRPr sz="1200" b="0">
+                <a:solidFill>
+                  <a:srgbClr val="5B6B7C"/>
+                </a:solidFill>
+                <a:latin typeface="DejaVu Sans"/>
+                <a:ea typeface="DejaVu Sans"/>
+                <a:cs typeface="DejaVu Sans"/>
+              </a:defRPr>
+            </a:defPPr>
+          </a:lstStyle>
+          <a:p xmlns:a="http://schemas.openxmlformats.org/drawingml/2006/main">
+            <a:pPr>
+              <a:defRPr sz="1200" b="0">
+                <a:solidFill>
+                  <a:srgbClr val="5B6B7C"/>
+                </a:solidFill>
+                <a:latin typeface="DejaVu Sans"/>
+                <a:ea typeface="DejaVu Sans"/>
+                <a:cs typeface="DejaVu Sans"/>
+              </a:defRPr>
+            </a:pPr>
+            <a:r>
+              <a:rPr sz="1200" b="0">
+                <a:solidFill>
+                  <a:srgbClr val="5B6B7C"/>
+                </a:solidFill>
+                <a:latin typeface="DejaVu Sans"/>
+                <a:ea typeface="DejaVu Sans"/>
+                <a:cs typeface="DejaVu Sans"/>
+              </a:rPr>
+              <a:t>SIMULATED API AUTOSCALING • PART 2</a:t>
+            </a:r>
+          </a:p>
+        </p:txBody>
+      </p:sp>
+      <p:sp>
+        <p:nvSpPr>
+          <p:cNvPr id="4" name="">
+            <a:extLst xmlns:a="http://schemas.openxmlformats.org/drawingml/2006/main">
+              <a:ext uri="{FF2B5EF4-FFF2-40B4-BE49-F238E27FC236}">
+                <a16:creationId xmlns:a16="http://schemas.microsoft.com/office/drawing/2014/main" id="{48B8AA12-0D8A-4229-A594-C9944F273771}"/>
+              </a:ext>
+            </a:extLst>
+          </p:cNvPr>
+          <p:cNvSpPr>
+            <a:spLocks xmlns:a="http://schemas.openxmlformats.org/drawingml/2006/main" noGrp="1"/>
+          </p:cNvSpPr>
+          <p:nvPr/>
+        </p:nvSpPr>
+        <p:spPr>
+          <a:xfrm xmlns:a="http://schemas.openxmlformats.org/drawingml/2006/main">
+            <a:off x="11182350" y="6381750"/>
+            <a:ext cx="476250" cy="342900"/>
+          </a:xfrm>
+          <a:prstGeom xmlns:a="http://schemas.openxmlformats.org/drawingml/2006/main" prst="rect">
+            <a:avLst/>
+          </a:prstGeom>
+          <a:noFill xmlns:a="http://schemas.openxmlformats.org/drawingml/2006/main"/>
+          <a:ln xmlns:a="http://schemas.openxmlformats.org/drawingml/2006/main" w="0">
+            <a:noFill/>
+          </a:ln>
+        </p:spPr>
+        <p:txBody>
+          <a:bodyPr xmlns:a="http://schemas.openxmlformats.org/drawingml/2006/main"/>
+          <a:lstStyle xmlns:a="http://schemas.openxmlformats.org/drawingml/2006/main">
+            <a:defPPr>
+              <a:defRPr sz="1425" b="0">
+                <a:solidFill>
+                  <a:srgbClr val="5B6B7C"/>
+                </a:solidFill>
+                <a:latin typeface="DejaVu Sans"/>
+                <a:ea typeface="DejaVu Sans"/>
+                <a:cs typeface="DejaVu Sans"/>
+              </a:defRPr>
+            </a:defPPr>
+          </a:lstStyle>
+          <a:p xmlns:a="http://schemas.openxmlformats.org/drawingml/2006/main">
+            <a:pPr>
+              <a:defRPr sz="1425" b="0">
+                <a:solidFill>
+                  <a:srgbClr val="5B6B7C"/>
+                </a:solidFill>
+                <a:latin typeface="DejaVu Sans"/>
+                <a:ea typeface="DejaVu Sans"/>
+                <a:cs typeface="DejaVu Sans"/>
+              </a:defRPr>
+            </a:pPr>
+            <a:r>
+              <a:rPr sz="1425" b="0">
+                <a:solidFill>
+                  <a:srgbClr val="5B6B7C"/>
+                </a:solidFill>
+                <a:latin typeface="DejaVu Sans"/>
+                <a:ea typeface="DejaVu Sans"/>
+                <a:cs typeface="DejaVu Sans"/>
+              </a:rPr>
+              <a:t>14</a:t>
+            </a:r>
+          </a:p>
+        </p:txBody>
+      </p:sp>
+      <p:graphicFrame>
+        <p:nvGraphicFramePr>
+          <p:cNvPr id="5" name="Chart">
+            <a:extLst xmlns:a="http://schemas.openxmlformats.org/drawingml/2006/main">
+              <a:ext uri="{FF2B5EF4-FFF2-40B4-BE49-F238E27FC236}">
+                <a16:creationId xmlns:a16="http://schemas.microsoft.com/office/drawing/2014/main" id="{A5AE8695-3FE3-4280-8608-BC5496B73902}"/>
+              </a:ext>
+            </a:extLst>
+          </p:cNvPr>
+          <p:cNvGraphicFramePr/>
+          <p:nvPr/>
+        </p:nvGraphicFramePr>
+        <p:xfrm>
+          <a:off xmlns:a="http://schemas.openxmlformats.org/drawingml/2006/main" x="628650" y="1914525"/>
+          <a:ext xmlns:a="http://schemas.openxmlformats.org/drawingml/2006/main" cx="10906125" cy="3286125"/>
+        </p:xfrm>
+        <a:graphic xmlns:a="http://schemas.openxmlformats.org/drawingml/2006/main">
+          <a:graphicData uri="http://schemas.openxmlformats.org/drawingml/2006/chart">
+            <c:chart xmlns:r="http://schemas.openxmlformats.org/officeDocument/2006/relationships" xmlns:c="http://schemas.openxmlformats.org/drawingml/2006/chart" r:id="R19525bc2e3804f1f"/>
+          </a:graphicData>
+        </a:graphic>
+      </p:graphicFrame>
+      <p:sp>
+        <p:nvSpPr>
+          <p:cNvPr id="6" name="">
+            <a:extLst xmlns:a="http://schemas.openxmlformats.org/drawingml/2006/main">
+              <a:ext uri="{FF2B5EF4-FFF2-40B4-BE49-F238E27FC236}">
+                <a16:creationId xmlns:a16="http://schemas.microsoft.com/office/drawing/2014/main" id="{4A8E0406-CF81-4E67-852F-ECFC3428F932}"/>
+              </a:ext>
+            </a:extLst>
+          </p:cNvPr>
+          <p:cNvSpPr>
+            <a:spLocks xmlns:a="http://schemas.openxmlformats.org/drawingml/2006/main" noGrp="1"/>
+          </p:cNvSpPr>
+          <p:nvPr/>
+        </p:nvSpPr>
+        <p:spPr>
+          <a:xfrm xmlns:a="http://schemas.openxmlformats.org/drawingml/2006/main">
+            <a:off x="628650" y="5476875"/>
+            <a:ext cx="10858500" cy="428625"/>
+          </a:xfrm>
+          <a:prstGeom xmlns:a="http://schemas.openxmlformats.org/drawingml/2006/main" prst="rect">
+            <a:avLst/>
+          </a:prstGeom>
+          <a:noFill xmlns:a="http://schemas.openxmlformats.org/drawingml/2006/main"/>
+          <a:ln xmlns:a="http://schemas.openxmlformats.org/drawingml/2006/main" w="0">
+            <a:noFill/>
+          </a:ln>
+        </p:spPr>
+        <p:txBody>
+          <a:bodyPr xmlns:a="http://schemas.openxmlformats.org/drawingml/2006/main"/>
+          <a:lstStyle xmlns:a="http://schemas.openxmlformats.org/drawingml/2006/main">
+            <a:defPPr>
+              <a:defRPr sz="2100" b="1">
+                <a:solidFill>
+                  <a:srgbClr val="DC7841"/>
+                </a:solidFill>
+                <a:latin typeface="DejaVu Sans"/>
+                <a:ea typeface="DejaVu Sans"/>
+                <a:cs typeface="DejaVu Sans"/>
+              </a:defRPr>
+            </a:defPPr>
+          </a:lstStyle>
+          <a:p xmlns:a="http://schemas.openxmlformats.org/drawingml/2006/main">
+            <a:pPr>
+              <a:defRPr sz="2100" b="1">
+                <a:solidFill>
+                  <a:srgbClr val="DC7841"/>
+                </a:solidFill>
+                <a:latin typeface="DejaVu Sans"/>
+                <a:ea typeface="DejaVu Sans"/>
+                <a:cs typeface="DejaVu Sans"/>
+              </a:defRPr>
+            </a:pPr>
+            <a:r>
+              <a:rPr sz="2100" b="1">
+                <a:solidFill>
+                  <a:srgbClr val="DC7841"/>
+                </a:solidFill>
+                <a:latin typeface="DejaVu Sans"/>
+                <a:ea typeface="DejaVu Sans"/>
+                <a:cs typeface="DejaVu Sans"/>
+              </a:rPr>
+              <a:t>Final: policy entropy 0.64 nats, executed entropy only 0.17 nats.</a:t>
+            </a:r>
+          </a:p>
+        </p:txBody>
+      </p:sp>
+      <p:sp>
+        <p:nvSpPr>
+          <p:cNvPr id="7" name="">
+            <a:extLst xmlns:a="http://schemas.openxmlformats.org/drawingml/2006/main">
+              <a:ext uri="{FF2B5EF4-FFF2-40B4-BE49-F238E27FC236}">
+                <a16:creationId xmlns:a16="http://schemas.microsoft.com/office/drawing/2014/main" id="{CE64199A-A205-4D2C-B48A-595A7D8A4434}"/>
+              </a:ext>
+            </a:extLst>
+          </p:cNvPr>
+          <p:cNvSpPr>
+            <a:spLocks xmlns:a="http://schemas.openxmlformats.org/drawingml/2006/main" noGrp="1"/>
+          </p:cNvSpPr>
+          <p:nvPr/>
+        </p:nvSpPr>
+        <p:spPr>
+          <a:xfrm xmlns:a="http://schemas.openxmlformats.org/drawingml/2006/main">
+            <a:off x="628650" y="5915025"/>
+            <a:ext cx="10858500" cy="352425"/>
+          </a:xfrm>
+          <a:prstGeom xmlns:a="http://schemas.openxmlformats.org/drawingml/2006/main" prst="rect">
+            <a:avLst/>
+          </a:prstGeom>
+          <a:noFill xmlns:a="http://schemas.openxmlformats.org/drawingml/2006/main"/>
+          <a:ln xmlns:a="http://schemas.openxmlformats.org/drawingml/2006/main" w="0">
+            <a:noFill/>
+          </a:ln>
+        </p:spPr>
+        <p:txBody>
+          <a:bodyPr xmlns:a="http://schemas.openxmlformats.org/drawingml/2006/main"/>
+          <a:lstStyle xmlns:a="http://schemas.openxmlformats.org/drawingml/2006/main">
+            <a:defPPr>
+              <a:defRPr sz="1725" b="0">
+                <a:solidFill>
+                  <a:srgbClr val="5B6B7C"/>
+                </a:solidFill>
+                <a:latin typeface="DejaVu Sans"/>
+                <a:ea typeface="DejaVu Sans"/>
+                <a:cs typeface="DejaVu Sans"/>
+              </a:defRPr>
+            </a:defPPr>
+          </a:lstStyle>
+          <a:p xmlns:a="http://schemas.openxmlformats.org/drawingml/2006/main">
+            <a:pPr>
+              <a:defRPr sz="1725" b="0">
+                <a:solidFill>
+                  <a:srgbClr val="5B6B7C"/>
+                </a:solidFill>
+                <a:latin typeface="DejaVu Sans"/>
+                <a:ea typeface="DejaVu Sans"/>
+                <a:cs typeface="DejaVu Sans"/>
+              </a:defRPr>
+            </a:pPr>
+            <a:r>
+              <a:rPr sz="1725" b="0">
+                <a:solidFill>
+                  <a:srgbClr val="5B6B7C"/>
+                </a:solidFill>
+                <a:latin typeface="DejaVu Sans"/>
+                <a:ea typeface="DejaVu Sans"/>
+                <a:cs typeface="DejaVu Sans"/>
+              </a:rPr>
+              <a:t>63% of probability is on rejected actions → mask invalid actions next.</a:t>
+            </a:r>
+          </a:p>
+        </p:txBody>
+      </p:sp>
+    </p:spTree>
+    <p:extLst>
+      <p:ext uri="{BB962C8B-B14F-4D97-AF65-F5344CB8AC3E}">
+        <p14:creationId xmlns:p14="http://schemas.microsoft.com/office/powerpoint/2010/main" val="322878168"/>
       </p:ext>
     </p:extLst>
   </p:cSld>
@@ -15958,7 +18131,7 @@
                 <a:ea typeface="DejaVu Sans"/>
                 <a:cs typeface="DejaVu Sans"/>
               </a:rPr>
-              <a:t>5 tests: gradients, terminal GAE, startup/accounting, reproducibility.</a:t>
+              <a:t>9 tests: gradients, GAE λ extremes, entropy, accounting, reproducibility.</a:t>
             </a:r>
           </a:p>
           <a:p xmlns:a="http://schemas.openxmlformats.org/drawingml/2006/main">
@@ -16392,7 +18565,7 @@
                           <a:ea typeface="DejaVu Sans"/>
                           <a:cs typeface="DejaVu Sans"/>
                         </a:rPr>
-                        <a:t>5 seeds × 50,000 decisions</a:t>
+                        <a:t>10 seeds × 50,000 decisions</a:t>
                       </a:r>
                     </a:p>
                   </a:txBody>
@@ -16668,7 +18841,7 @@
                 <a:ea typeface="DejaVu Sans"/>
                 <a:cs typeface="DejaVu Sans"/>
               </a:rPr>
-              <a:t>PPO: 5 policies × 30 common traces. Means of episode metrics.</a:t>
+              <a:t>PPO: 10 policies × 30 common traces. 95% CIs across seeds.</a:t>
             </a:r>
           </a:p>
         </p:txBody>

</xml_diff>

<commit_message>
Match slide and guide AI disclosure to README
Co-Authored-By: Claude Opus 5.5 <noreply@anthropic.com>
</commit_message>
<xml_diff>
--- a/presentation/API_Autoscaling_RL_Presentation.pptx
+++ b/presentation/API_Autoscaling_RL_Presentation.pptx
@@ -1099,7 +1099,7 @@
           </a:p>
           <a:p xmlns:a="http://schemas.openxmlformats.org/drawingml/2006/main">
             <a:r>
-              <a:t>The references connect back to Part 1, and full links are in the repository. OpenAI ChatGPT and Anthropic Claude helped implement and test code, run and analyze the experiments, and draft these slides and narration. I need to review that assistance, verify the sources, and explain the work in my own words. The results come from actual simulator runs.</a:t>
+              <a:t>The references connect back to Part 1, and full links are in the repository. OpenAI ChatGPT and Anthropic Claude helped implement and test code, run and analyze the experiments, and draft these slides and narration. The results come from actual simulator runs.</a:t>
             </a:r>
           </a:p>
           <a:p xmlns:a="http://schemas.openxmlformats.org/drawingml/2006/main">
@@ -12116,7 +12116,7 @@
                 <a:ea typeface="DejaVu Sans"/>
                 <a:cs typeface="DejaVu Sans"/>
               </a:rPr>
-              <a:t>Review the work, verify sources, and present your own understanding.</a:t>
+              <a:t>Training metrics come from actual executions of the included simulator.</a:t>
             </a:r>
           </a:p>
         </p:txBody>

</xml_diff>

<commit_message>
Add course and instructor to title slide
Co-Authored-By: Claude Opus 5.5 <noreply@anthropic.com>
</commit_message>
<xml_diff>
--- a/presentation/API_Autoscaling_RL_Presentation.pptx
+++ b/presentation/API_Autoscaling_RL_Presentation.pptx
@@ -7341,6 +7341,66 @@
       </p:sp>
       <p:sp>
         <p:nvSpPr>
+          <p:cNvPr id="9" name="Course"/>
+          <p:cNvSpPr>
+            <a:spLocks xmlns:a="http://schemas.openxmlformats.org/drawingml/2006/main" noGrp="1"/>
+          </p:cNvSpPr>
+          <p:nvPr/>
+        </p:nvSpPr>
+        <p:spPr>
+          <a:xfrm xmlns:a="http://schemas.openxmlformats.org/drawingml/2006/main">
+            <a:off x="628650" y="1238250"/>
+            <a:ext cx="10572750" cy="457200"/>
+          </a:xfrm>
+          <a:prstGeom xmlns:a="http://schemas.openxmlformats.org/drawingml/2006/main" prst="rect">
+            <a:avLst/>
+          </a:prstGeom>
+          <a:noFill xmlns:a="http://schemas.openxmlformats.org/drawingml/2006/main"/>
+          <a:ln xmlns:a="http://schemas.openxmlformats.org/drawingml/2006/main" w="0">
+            <a:noFill/>
+          </a:ln>
+        </p:spPr>
+        <p:txBody>
+          <a:bodyPr xmlns:a="http://schemas.openxmlformats.org/drawingml/2006/main"/>
+          <a:lstStyle xmlns:a="http://schemas.openxmlformats.org/drawingml/2006/main">
+            <a:defPPr>
+              <a:defRPr sz="2025" b="0">
+                <a:solidFill>
+                  <a:srgbClr val="5B6B7C"/>
+                </a:solidFill>
+                <a:latin typeface="DejaVu Sans"/>
+                <a:ea typeface="DejaVu Sans"/>
+                <a:cs typeface="DejaVu Sans"/>
+              </a:defRPr>
+            </a:defPPr>
+          </a:lstStyle>
+          <a:p xmlns:a="http://schemas.openxmlformats.org/drawingml/2006/main">
+            <a:pPr>
+              <a:defRPr sz="2025" b="0">
+                <a:solidFill>
+                  <a:srgbClr val="5B6B7C"/>
+                </a:solidFill>
+                <a:latin typeface="DejaVu Sans"/>
+                <a:ea typeface="DejaVu Sans"/>
+                <a:cs typeface="DejaVu Sans"/>
+              </a:defRPr>
+            </a:pPr>
+            <a:r>
+              <a:rPr sz="2025" b="0">
+                <a:solidFill>
+                  <a:srgbClr val="5B6B7C"/>
+                </a:solidFill>
+                <a:latin typeface="DejaVu Sans"/>
+                <a:ea typeface="DejaVu Sans"/>
+                <a:cs typeface="DejaVu Sans"/>
+              </a:rPr>
+              <a:t>AI-830-A02 • Instructor: Dr. Soamar Homsi, PhD</a:t>
+            </a:r>
+          </a:p>
+        </p:txBody>
+      </p:sp>
+      <p:sp>
+        <p:nvSpPr>
           <p:cNvPr id="7" name="">
             <a:extLst xmlns:a="http://schemas.openxmlformats.org/drawingml/2006/main">
               <a:ext uri="{FF2B5EF4-FFF2-40B4-BE49-F238E27FC236}">

</xml_diff>